<commit_message>
make example_5 output reproducible
</commit_message>
<xml_diff>
--- a/documentation/example_5/shuffling.pptx
+++ b/documentation/example_5/shuffling.pptx
@@ -5,10 +5,11 @@
     <p:sldMasterId id="2147483732" r:id="rId1"/>
   </p:sldMasterIdLst>
   <p:notesMasterIdLst>
-    <p:notesMasterId r:id="rId3"/>
+    <p:notesMasterId r:id="rId4"/>
   </p:notesMasterIdLst>
   <p:sldIdLst>
-    <p:sldId id="258" r:id="rId2"/>
+    <p:sldId id="256" r:id="rId2"/>
+    <p:sldId id="258" r:id="rId3"/>
   </p:sldIdLst>
   <p:sldSz cx="9899650" cy="2879725"/>
   <p:notesSz cx="6858000" cy="9144000"/>
@@ -169,6 +170,61 @@
           <inkml:channelProperty channel="F" name="resolution" value="0" units="1/dev"/>
         </inkml:channelProperties>
       </inkml:inkSource>
+      <inkml:timestamp xml:id="ts0" timeString="2019-09-17T16:46:39.312"/>
+    </inkml:context>
+    <inkml:brush xml:id="br0">
+      <inkml:brushProperty name="width" value="0.34286" units="cm"/>
+      <inkml:brushProperty name="height" value="0.34286" units="cm"/>
+      <inkml:brushProperty name="color" value="#0D0D0D"/>
+    </inkml:brush>
+  </inkml:definitions>
+  <inkml:trace contextRef="#ctx0" brushRef="#br0">2225 4605 8027,'11'-39'0,"0"3"0,-8 21 0,2-2 0,0 3 0,0-1 0,2-1 0,1-2 0,-1 0 0,2-1 0,-2 0 0,0-1 0,0 0 0,1 0 0,0-1 0,-2 2 0,0-1 0,1 2 0,-2-1 0,1 1 0,0 0 0,0-1 0,-1 1 0,-1-2 0,0 2 0,1-2 0,-1 1 0,0-3 0,0 2 0,1 0 0,-2-1 0,1 3 0,1-3 0,-1 1 0,0 1 0,-1-1 0,0-1 0,-2 0 0,2 0 0,-2 0 0,0 0 0,1 0 0,0 0 0,-1 0 0,-1 0 0,1 0 0,1 0 0,0 2 0,-2 1 0,0 0 0,0 2 0,0-1 0,0 1 0,0-2 0,0 2 0,0 1 0,-1-1 0,-1 0 0,-1 1 0,-2-1 0,0 2 0,-3-2 0,3 0 0,-1 2 0,-2 1 0,-2 0 0,1 0 0,-2 1 0,1-1 0,-2 0 0,0 2 0,-2 0 0,-1 1 0,-1-2 0,-1 1 0,1 1 0,-1-2 0,0 2 0,0-1 0,0 0 0,1 1 0,-1 1 0,1-2 0,-2 1 0,0-1 0,0 1 0,-2-1 0,0 0 0,-4-2 0,2 1 0,-4 0 0,6 3 0,-4-2 0,1 1 0,-3-1 0,3 1 0,2 1 0,-2 1 0,1-1 0,0 1 0,0 0 0,0-1 0,-2-1 0,0 1 0,0-2 0,3 4 0,-1-1 0,-4-1 0,1 3 0,1-3 0,0 0 0,2 3 0,-1-2 0,1-1 0,-2 0 0,-2-1 0,0 1 0,2 1 0,-4-1 0,3 0 0,-1-2 0,3 1 0,-5-1 0,-2-1 0,2 1 0,3 0 0,1 0 0,0-1 0,-3-2 0,0 2 0,-3-2 0,1 2 0,0-2 0,4 2 0,-3 0 0,6 0 0,-5-3 0,-1 1 0,5 1 0,-3-3 0,4 4 0,-3-7 0,2 4 0,-3-2 0,-1 0 0,1-1 0,-1-3 0,0 3 0,0-3 0,1 1 0,0 0 0,1 0 0,3 3 0,2-2 0,-4 0 0,1-4 0,-2 2 0,2 0 0,1 2 0,3 1 0,-2-4 0,5 4 0,-4-3 0,2 1 0,0 1 0,-2-4 0,4 4 0,0-4 0,3 3 0,1-1 0,-1-1 0,2 1 0,2-2 0,-1 1 0,2-2 0,-3-1 0,5-1 0,0 3 0,-2 1 0,4 0 0,-2-1 0,1 0 0,1 2 0,0-2 0,0 2 0,2 0 0,-1 0 0,2 0 0,1 0 0,-2 2 0,1-1 0,1 0 0,0-1 0,0 0 0,0 1 0,0 0 0,0 2 0,0 1 0,0 0 0,0 0 0,0 0 0,3 0 0,-1 1 0,2-1 0,0 1 0,0-2 0,0 1 0,2 0 0,1-1 0,1 1 0,-1-1 0,2 0 0,0 2 0,0-1 0,1 0 0,0 1 0,1 1 0,-2 2 0,2-1 0,1 0 0,0 1 0,3 1 0,-1 0 0,1 1 0,-1-1 0,1 1 0,0 1 0,0-2 0,2 1 0,-1 0 0,-2-1 0,2 1 0,-2 0 0,2 0 0,0 0 0,-1-2 0,1 2 0,2 0 0,-1 1 0,1-1 0,1 2 0,1-2 0,0 1 0,0 2 0,3 0 0,-1 0 0,-1 0 0,1 0 0,-2-1 0,1 3 0,-2-1 0,1 2 0,-1-1 0,0 1 0,1 1 0,1 0 0,-1-1 0,2 3 0,-2-2 0,2 4 0,1-1 0,-2-1 0,1 0 0,1 1 0,-1 1 0,0 0 0,-1 0 0,-2 0 0,1 0 0,0 0 0,0 0 0,0 0 0,0 0 0,0 0 0,1 0 0,2 0 0,1 1 0,-2 3 0,3-1 0,-6 1 0,3 1 0,-2-1 0,0 0 0,0 1 0,-2 1 0,0-1 0,-1 2 0,1-1 0,1 3 0,1-1 0,-2 0 0,3 1 0,-3-1 0,0 3 0,2-2 0,-1 2 0,0-1 0,-1 1 0,0-1 0,0 0 0,-2 0 0,-1-1 0,1 2 0,-2-1 0,0 2 0,-1-3 0,-1 3 0,1-3 0,-1 2 0,0-1 0,1 2 0,-2-3 0,1 3 0,-1-1 0,0 0 0,1 1 0,-1 1 0,1 0 0,-1 1 0,1-2 0,-1 1 0,1 1 0,-1 0 0,0 1 0,0-1 0,-1 1 0,0-2 0,1 1 0,-1 0 0,0-2 0,-2 1 0,1 0 0,0-1 0,-1 3 0,0-2 0,0 0 0,-1 0 0,1-1 0,-3 2 0,1-2 0,0 1 0,-2 0 0,2 2 0,-1-2 0,1 1 0,-1 1 0,1-3 0,-2 2 0,0 1 0,1-1 0,-2 0 0,1-1 0,1 0 0,0 0 0,1-1 0,-1 1 0,0-2 0,1 6 0,0 0 0,2 4 0,-1 0 0,1 0 0,-5-6 0,2 0 0,-3-5 0,1 1 0,1 0 0,-1 0 0,-2 0 0,4 2 0,-3 2 0,1-3 0,-1 0 0,-1-3 0,3 3 0,-4-2 0,2 1 0,0-3 0,0 6 0,1-1 0,0 2 0,-2 0 0,0 0 0,2-2 0,-1 1 0,0-1 0,2 6 0,-4-2 0,2-1 0,1-3 0,-3 0 0,3 0 0,-1-1 0,-1-1 0,2 1 0,-1-1 0,-1 0 0,-1-1 0,2 1 0,0-1 0,-1 2 0,2-3 0,-2 2 0,1-2 0,-1 5 0,2 2 0,1-1 0,1 3 0,-2-3 0,0-4 0,1 7 0,-3-9 0,4 9 0,-3-3 0,2 2 0,-3 0 0,2-3 0,-2 3 0,2-4 0,-1 3 0,1-2 0,1-2 0,-4 0 0,4-1 0,-4 3 0,4 0 0,-2 0 0,1-2 0,1 1 0,-2 0 0,0-1 0,2 1 0,-3-4 0,0 4 0,1-4 0,-1 8 0,2-4 0,0 4 0,-1-5 0,2 5 0,-3-3 0,1 3 0,-1-4 0,3 3 0,-2-3 0,2 2 0,-1 2 0,0-4 0,-2 0 0,3-1 0,-4-4 0,4 4 0,-3-3 0,0 2 0,1 1 0,1-3 0,-1 5 0,0-6 0,0 3 0,-2-3 0,2 1 0,0 1 0,1 0 0,-2 1 0,4 0 0,-4-3 0,2 3 0,1-3 0,-2 4 0,2-1 0,0 2 0,1-2 0,-1 0 0,0-1 0,1 2 0,1-2 0,-1 3 0,2 0 0,1-1 0,-3 0 0,3 1 0,-1 0 0,0-1 0,2-1 0,-2-1 0,1-1 0,-2-1 0,3 2 0,-1-1 0,2 2 0,-1-3 0,2 3 0,-3-3 0,2 2 0,-1-1 0,2-1 0,-3-2 0,4 2 0,-5-1 0,3 2 0,-2-1 0,1-2 0,1 3 0,-1-5 0,1 2 0,0-2 0,-3 0 0,3 1 0,-4-1 0,3 0 0,1-2 0,-1 2 0,1-4 0,-1 2 0,-1-2 0,1 0 0,1 0 0,-1 0 0,1 0 0,-2 0 0,1 0 0,0 0 0,-2 0 0,2 0 0,-1-2 0,1-2 0,1-3 0,-3 1 0,4 0 0,-3 0 0,4-1 0,-4-1 0,3 0 0,-4 1 0,2 0 0,0-2 0,2-2 0,1-1 0,-3-1 0,-1 5 0,2-4 0,-1 5 0,2-5 0,1-1 0,-4 0 0,2-2 0,-1 3 0,0-3 0,-1 0 0,-2 2 0,3-3 0,-4 4 0,2-5 0,-2 5 0,2-2 0,-1 4 0,-1-2 0,0 0 0,1-4 0,0-1 0,2-3 0,-1 2 0,-1 1 0,-1 2 0,1 0 0,0 1 0,-2-2 0,0 3 0,0-2 0,1 1 0,-1 0 0,0-1 0,0-2 0,1 2 0,-1-3 0,-1 0 0,2-1 0,-3 3 0,2-1 0,-1 0 0,0 0 0,0 0 0,1 2 0,-2-1 0,1 1 0,-1-1 0,0-1 0,1-1 0,-2 0 0,2-1 0,-1 1 0,0-2 0,0 0 0,-1-2 0,-1 2 0,1 0 0,1 0 0,-1 2 0,-1-1 0,0 1 0,0 0 0,0-1 0,0 1 0,0-1 0,0 1 0,0-1 0,0-1 0,0 1 0,-2-1 0,-2-1 0,0 0 0,-2 0 0,0 1 0,1 0 0,-3 0 0,1 2 0,0-1 0,0 0 0,0 1 0,1 1 0,-2-1 0,3 0 0,-3-1 0,1 1 0,0-1 0,1-1 0,-2 1 0,2 0 0,-1-1 0,0 0 0,0 0 0,0 1 0,-1 1 0,2 1 0,-1 0 0,-1 2 0,1-1 0,-2 2 0,1-1 0,0 0 0,-1 0 0,2 0 0,-3-2 0,0 2 0,1 0 0,-3-2 0,2-1 0,-1 0 0,1 0 0,-1 0 0,-2 1 0,2-1 0,0 0 0,-1 1 0,0 0 0,0-1 0,2 0 0,1-1 0,-2-1 0,0 0 0,-1-1 0,4 2 0,-2-2 0,0-1 0,0 0 0,1 3 0,2-1 0,-2-1 0,1 1 0,-1 2 0,0-3 0,1 0 0,0 1 0,0-1 0,-1 0 0,1 0 0,1 0 0,-1 0 0,1-1 0,0 2 0,0-2 0,1 4 0,-1-2 0,0 0 0,1-1 0,1 1 0,0 0 0,1 2 0,2-1 0,-2-1 0,3 1 0,-2 0 0,2-1 0,0 0 0,0 0 0,1 1 0,0-1 0,0 1 0,0 1 0,0 0 0,0 0 0,0 0 0,2 2 0,1-1 0,1 2 0,0-1 0,0 1 0,2 0 0,0 2 0,1-2 0,1 2 0,0 0 0,-1-1 0,0 4 0,0-1 0,0 1 0,3 0 0,0-1 0,-2 2 0,2 1 0,-2 2 0,5-1 0,0 1 0,1 1 0,2 2 0,-3-1 0,-1 1 0,0 1 0,0 1 0,1-1 0,-1 0 0,2-1 0,0 0 0,-2 0 0,3 2 0,-1-1 0,0 1 0,2 0 0,-3 0 0,1 0 0,-1 1 0,1 0 0,0 0 0,0 0 0,-1 0 0,-1 0 0,0 0 0,1 0 0,0 0 0,0 0 0,1 0 0,-1 0 0,3 1 0,-2 0 0,2 1 0,-1 3 0,1-1 0,0 0 0,0 1 0,-1-1 0,2 0 0,-1-1 0,-1 2 0,1-1 0,-2 0 0,2 1 0,-3-1 0,1 0 0,-1 0 0,0 1 0,-1-1 0,0-1 0,1 2 0,0-1 0,1 0 0,0 1 0,-1 1 0,1-1 0,0 0 0,-1 0 0,1-1 0,1 0 0,-2 0 0,3 0 0,-3 0 0,3-1 0,-2-1 0,2-1 0,-3 0 0,1 0 0,-1 0 0,0-1 0,-2 0 0,0 0 0,0 2 0,2-1 0,-2 0 0,0-1 0,-1 0 0,1 0 0,1 0 0,3 0 0,1 0 0,-1 0 0,-3 0 0,1 0 0,0 0 0,-1 0 0,0-1 0,5-3 0,0 0 0,-2-1 0,-4 2 0,1 0 0,0 0 0,1-1 0,0 1 0,-1 0 0,1-1 0,0-1 0,3-1 0,1 0 0,3-3 0,0-1 0,-4 5 0,2-4 0,-2 5 0,-1-1 0,-3 0 0,1 1 0,2-1 0,1-1 0,0 1 0,-2 1 0,-2 0 0,0 2 0,0-1 0,1-1 0,-1 0 0,0 1 0,1 0 0,-1 0 0,4-1 0,-1-1 0,0 3 0,-2-1 0,0 1 0,-1-3 0,1 3 0,0-2 0,0 2 0,0-3 0,1 3 0,1-2 0,1 3 0,1-3 0,0 2 0,-1 0 0,1-1 0,0 2 0,0-2 0,0 2 0,-1-2 0,1 0 0,-1 1 0,2-2 0,-3 4 0,1-4 0,0 3 0,-2-2 0,2 2 0,-1-2 0,2 2 0,-1-2 0,1 1 0,1 1 0,0-1 0,3 2 0,-1-2 0,-1 1 0,2 1 0,-2-1 0,0 1 0,1-2 0,-2 2 0,-1 0 0,0 0 0,-1 0 0,1 0 0,-2 0 0,1 0 0,-2 0 0,1 0 0,0 0 0,0 0 0,-1 0 0,2 0 0,-3 0 0,3 0 0,0 0 0,-2 0 0,1 0 0,-1 2 0,-1-1 0,1 1 0,-1 1 0,0 1 0,-2 0 0,0 1 0,0-1 0,5 2 0,0 0 0,0 1 0,-2-1 0,-3-2 0,-1 0 0,1 0 0,-1 1 0,4 2 0,0-1 0,4 5 0,-3-4 0,0 1 0,-4-1 0,-2 0 0,2 0 0,1-1 0,3 5 0,0-2 0,-1 1 0,-2-4 0,-3 3 0,3-2 0,-3 1 0,0 0 0,1 1 0,-2-1 0,0 0 0,1 0 0,1 4 0,-1-1 0,2 3 0,-3-3 0,1 0 0,-3-2 0,1-1 0,-1 1 0,-1 1 0,2-1 0,-1 6 0,3-2 0,-1 2 0,-2-4 0,-1 1 0,2 0 0,-1 0 0,0 0 0,2 1 0,-2 1 0,1 0 0,0 0 0,0 0 0,0 0 0,-2 1 0,3-1 0,-1 0 0,-1 0 0,2 4 0,-2 0 0,-1-1 0,-1-4 0,0 0 0,1-1 0,-1 1 0,0 1 0,0 1 0,-1 0 0,0 1 0,-2-1 0,0 2 0,-1 1 0,0 0 0,0 1 0,0-3 0,0 1 0,0 0 0,0 1 0,0 0 0,0 0 0,-1-1 0,-3 0 0,-2 0 0,-1 1 0,2 1 0,-4 0 0,1 1 0,-1 0 0,-2 1 0,2-1 0,-2 0 0,1 0 0,-2 0 0,1-1 0,0 2 0,0-2 0,0 0 0,-2 1 0,0-2 0,1 2 0,-1-2 0,-1 1 0,-2 0 0,-3 3 0,1-5 0,-3 4 0,5-6 0,-4 4 0,2-3 0,-5 1 0,1 0 0,0 0 0,0-1 0,1 1 0,-3 2 0,3-4 0,-2 2 0,3-3 0,-4 4 0,1-1 0,-1-1 0,-1 0 0,0 0 0,2-3 0,1 1 0,1-2 0,-3 2 0,1 1 0,-1-1 0,1-1 0,1-2 0,0 1 0,-4 0 0,0 0 0,2 0 0,0-1 0,1-3 0,-3 3 0,1-3 0,0 1 0,-1 0 0,2 1 0,0 0 0,0-2 0,2 1 0,-1 1 0,1-1 0,0 1 0,-3-2 0,1 1 0,-3 1 0,5-3 0,-2 2 0,3-2 0,-3 2 0,2-2 0,-1 0 0,2 0 0,0-1 0,2 1 0,-1-2 0,2 0 0,-2 1 0,1 0 0,0 0 0,-2 0 0,2-1 0,-2 0 0,2 0 0,-2 0 0,1-1 0,1 1 0,-1 0 0,0 1 0,2-1 0,0-1 0,1 0 0,0 1 0,1-1 0,0 0 0,0 1 0,2-1 0,0-1 0,0 2 0,1-1 0,-1 0 0,1-1 0,0 0 0,2-2 0,0 2 0,-1-2 0,0 3 0,-3-2 0,-1 3 0,2-3 0,3 1 0,2-2 0,-5 3 0,1-2 0,2 2 0,-3 0 0,1 0 0,-2 1 0,-1-1 0,2 1 0,-1 1 0,5-3 0,-3 2 0,3-4 0,-1 4 0,-2-1 0,0 0 0,3 1 0,-1-1 0,3 0 0,-3 2 0,3-2 0,-2 2 0,1-1 0,1-1 0,-1 0 0,3 0 0,-3 1 0,5-1 0,-4 0 0,2 1 0,-1-1 0,-1 2 0,4-2 0,-5 0 0,3 0 0,-1-2 0,1 3 0,0-1 0,1-1 0,-1 0 0,0 1 0,2 1 0,-2 1 0,2-2 0,-1 0 0,1 0 0,2 1 0,-2-1 0,2 0 0,-3 0 0,4 2 0,-4 1 0,5-1 0,-4 0 0,4-1 0,-4 1 0,4 0 0,-4 3 0,4-3 0,-2 2 0,0 0 0,1 2 0,0 0 0,-1-2 0,1 0 0,-2 1 0,2-1 0,-3 1 0,3-1 0,-2 3 0,2-3 0,-1 2 0,2-1 0,0 0 0,0-2 0,0 2 0,0 1 0,0-1 0,0 2 0,0-2 0,0 1 0,0 2 0,0-1 0,0 2 0,0 1 0,0 2 0,0-1 0,0 2 0,0-1 0,1 1 0,0-2 0,2-2 0,1 1 0,0-1 0,1 2 0,-1-1 0,2 1 0,-2-1 0,5 3 0,-3 1 0,1-2 0,1-1 0,0 3 0,-1-2 0,0 1 0,0-2 0,1-5 0,-3 1 0,0-2 0,2 0 0,1 5 0,3-1 0,2 4 0,-3-1 0,0-3 0,0 0 0,-1-3 0,-2-1 0,5 3 0,-4-1 0,3 4 0,1-3 0,0 3 0,-2-3 0,0-1 0,-3-1 0,0-1 0,-2-1 0,5 4 0,0 2 0,0-2 0,-1-1 0,1 0 0,-3-1 0,3 0 0,-1-1 0,1-2 0,-1 2 0,1-1 0,0 1 0,2-1 0,-1-2 0,0 2 0,0-3 0,0 3 0,5 0 0,-1 0 0,0-1 0,-2-3 0,-1 1 0,1 0 0,0 0 0,-1 0 0,3 2 0,1-1 0,-1 0 0,1-1 0,-1 1 0,-1-1 0,-2-1 0,-1 0 0,1-1 0,0 1 0,-1-2 0,0 1 0,1-1 0,1 0 0,0 1 0,-1 0 0,0 0 0,1-1 0,1 0 0,0 0 0,0 0 0,-1 1 0,-1-2 0,1-1 0,0 2 0,-1-1 0,0 0 0,1 0 0,0 0 0,3-1 0,-1 0 0,-1 0 0,-3 0 0,0 0 0,2 0 0,2 0 0,0 0 0,1 0 0,-1 0 0,1 0 0,-1-2 0,1-1 0,-1-1 0,-1 0 0,-3-1 0,0 4 0,3-4 0,0 0 0,-2 0 0,3-1 0,-3-1 0,4-1 0,-5-1 0,0 2 0,-1-4 0,2 1 0,0-1 0,-1 1 0,0-1 0,-3-1 0,3-2 0,0 2 0,-4 2 0,1-1 0,1-4 0,2-1 0,0 0 0,-3 2 0,3 0 0,-3 0 0,1 1 0,1-2 0,0 1 0,-1-1 0,-1 0 0,2 2 0,-1-2 0,0 2 0,1 0 0,-1-2 0,-2 1 0,0-2 0,0 3 0,1-4 0,-1 3 0,0-3 0,-1 0 0,1 0 0,-2 1 0,0-1 0,1 0 0,-3 0 0,1 2 0,1 0 0,-1-1 0,0 1 0,0-1 0,1 2 0,-3 0 0,1 0 0,-2 1 0,2-1 0,-1 0 0,0 2 0,-1-2 0,1 0 0,0-1 0,-1 1 0,0 0 0,-1 0 0,0 0 0,2 0 0,0-1 0,-2 4 0,0-3 0,0 3 0,0-1 0,0 1 0,0-4 0,0 1 0,0-5 0,0 2 0,0-1 0,0 6 0,0-5 0,0 6 0,0-6 0,0 0 0,0 2 0,0-1 0,0 1 0,0-2 0,1 2 0,0 1 0,0 3 0,1-1 0,-2 4 0,0-2 0,1 2 0,0-4 0,1 1 0,0 1 0,-1-3 0,2 3 0,-2-3 0,2 1 0,0-1 0,-1 2 0,2-1 0,-2 2 0,2-5 0,-2 2 0,3-1 0,-1 1 0,0 0 0,2 0 0,-1 1 0,1-2 0,-4 4 0,6-3 0,-4 4 0,3-2 0,1-1 0,-2 4 0,3-4 0,0 2 0,-2 0 0,2 1 0,-1 5 0,3-4 0,-1 5 0,2-4 0,-4 4 0,7-4 0,-4 3 0,6-2 0,0 2 0,0 1 0,1-2 0,0 1 0,-3 0 0,2 0 0,-3-1 0,2 1 0,-2 1 0,-3 0 0,-1 2 0,1 0 0,-1 0 0,1-1 0,0 0 0,4 1 0,1 0 0,1 0 0,-4 1 0,2 0 0,-2 0 0,1 0 0,-1 0 0,1 0 0,-1 0 0,0 0 0,0 0 0,2 0 0,-1 0 0,-2 0 0,0 0 0,-1 0 0,0 0 0,2 1 0,1 2 0,-1-1 0,1 4 0,-2-2 0,4 3 0,-5-1 0,-2 0 0,-2-1 0,5 4 0,-3-3 0,5 7 0,-3-4 0,0 4 0,-3-3 0,2 0 0,-3 0 0,2 0 0,-2-2 0,-2 0 0,3 2 0,-1 0 0,-1-1 0,2 3 0,-1-1 0,1 4 0,2-2 0,-2 3 0,3-2 0,-4-2 0,2 0 0,-1 0 0,1 2 0,-2-2 0,3 0 0,-3 2 0,4 2 0,-3-1 0,2 2 0,-2-3 0,1 2 0,1 0 0,-3-3 0,0-4 0,-2 2 0,6 4 0,-4-1 0,4 3 0,-1-2 0,-2-1 0,0-6 0,1 6 0,-2-7 0,0 0 0,0 0 0,0 1 0,0-3 0,3 4 0,-1-1 0,-1 0 0,4 0 0,-2-1 0,4 1 0,-2 0 0,3 0 0,-2-1 0,1-2 0,-3-1 0,1-1 0,-3 0 0,3 1 0,-3 0 0,1-2 0,1 2 0,-3-2 0,2 1 0,1 0 0,-2 0 0,1-1 0,-2 2 0,1-4 0,-1 2 0,1-2 0,-2 0 0,-4 2 0,1-1 0,1 8 0,1 0 0</inkml:trace>
+</inkml:ink>
+</file>
+
+<file path=ppt/ink/ink3.xml><?xml version="1.0" encoding="utf-8"?>
+<inkml:ink xmlns:inkml="http://www.w3.org/2003/InkML">
+  <inkml:definitions>
+    <inkml:context xml:id="ctx0">
+      <inkml:inkSource xml:id="inkSrc0">
+        <inkml:traceFormat>
+          <inkml:channel name="X" type="integer" min="-2.14748E9" max="2.14748E9" units="cm"/>
+          <inkml:channel name="Y" type="integer" min="-2.14748E9" max="2.14748E9" units="cm"/>
+          <inkml:channel name="F" type="integer" max="32767" units="dev"/>
+        </inkml:traceFormat>
+        <inkml:channelProperties>
+          <inkml:channelProperty channel="X" name="resolution" value="1000" units="1/cm"/>
+          <inkml:channelProperty channel="Y" name="resolution" value="1000" units="1/cm"/>
+          <inkml:channelProperty channel="F" name="resolution" value="0" units="1/dev"/>
+        </inkml:channelProperties>
+      </inkml:inkSource>
+      <inkml:timestamp xml:id="ts0" timeString="2019-09-17T16:44:10.086"/>
+    </inkml:context>
+    <inkml:brush xml:id="br0">
+      <inkml:brushProperty name="width" value="0.2" units="cm"/>
+      <inkml:brushProperty name="height" value="0.2" units="cm"/>
+    </inkml:brush>
+  </inkml:definitions>
+  <inkml:trace contextRef="#ctx0" brushRef="#br0">0 1 24575,'0'0'0</inkml:trace>
+</inkml:ink>
+</file>
+
+<file path=ppt/ink/ink4.xml><?xml version="1.0" encoding="utf-8"?>
+<inkml:ink xmlns:inkml="http://www.w3.org/2003/InkML">
+  <inkml:definitions>
+    <inkml:context xml:id="ctx0">
+      <inkml:inkSource xml:id="inkSrc0">
+        <inkml:traceFormat>
+          <inkml:channel name="X" type="integer" min="-2.14748E9" max="2.14748E9" units="cm"/>
+          <inkml:channel name="Y" type="integer" min="-2.14748E9" max="2.14748E9" units="cm"/>
+          <inkml:channel name="F" type="integer" max="32767" units="dev"/>
+        </inkml:traceFormat>
+        <inkml:channelProperties>
+          <inkml:channelProperty channel="X" name="resolution" value="1000" units="1/cm"/>
+          <inkml:channelProperty channel="Y" name="resolution" value="1000" units="1/cm"/>
+          <inkml:channelProperty channel="F" name="resolution" value="0" units="1/dev"/>
+        </inkml:channelProperties>
+      </inkml:inkSource>
       <inkml:timestamp xml:id="ts0" timeString="2019-09-19T14:24:56.398"/>
     </inkml:context>
     <inkml:brush xml:id="br0">
@@ -262,7 +318,7 @@
           <a:p>
             <a:fld id="{A42285C3-E257-5246-8AB1-F9357EC0BAFF}" type="datetimeFigureOut">
               <a:rPr lang="en-US" smtClean="0"/>
-              <a:t>9/20/19</a:t>
+              <a:t>9/19/19</a:t>
             </a:fld>
             <a:endParaRPr lang="en-US"/>
           </a:p>
@@ -609,6 +665,95 @@
     </p:spTree>
     <p:extLst>
       <p:ext uri="{BB962C8B-B14F-4D97-AF65-F5344CB8AC3E}">
+        <p14:creationId xmlns:p14="http://schemas.microsoft.com/office/powerpoint/2010/main" val="2196167824"/>
+      </p:ext>
+    </p:extLst>
+  </p:cSld>
+  <p:clrMapOvr>
+    <a:masterClrMapping/>
+  </p:clrMapOvr>
+</p:notes>
+</file>
+
+<file path=ppt/notesSlides/notesSlide2.xml><?xml version="1.0" encoding="utf-8"?>
+<p:notes xmlns:a="http://schemas.openxmlformats.org/drawingml/2006/main" xmlns:r="http://schemas.openxmlformats.org/officeDocument/2006/relationships" xmlns:p="http://schemas.openxmlformats.org/presentationml/2006/main">
+  <p:cSld>
+    <p:spTree>
+      <p:nvGrpSpPr>
+        <p:cNvPr id="1" name=""/>
+        <p:cNvGrpSpPr/>
+        <p:nvPr/>
+      </p:nvGrpSpPr>
+      <p:grpSpPr>
+        <a:xfrm>
+          <a:off x="0" y="0"/>
+          <a:ext cx="0" cy="0"/>
+          <a:chOff x="0" y="0"/>
+          <a:chExt cx="0" cy="0"/>
+        </a:xfrm>
+      </p:grpSpPr>
+      <p:sp>
+        <p:nvSpPr>
+          <p:cNvPr id="2" name="Slide Image Placeholder 1"/>
+          <p:cNvSpPr>
+            <a:spLocks noGrp="1" noRot="1" noChangeAspect="1"/>
+          </p:cNvSpPr>
+          <p:nvPr>
+            <p:ph type="sldImg"/>
+          </p:nvPr>
+        </p:nvSpPr>
+        <p:spPr>
+          <a:xfrm>
+            <a:off x="-1874838" y="1143000"/>
+            <a:ext cx="10607676" cy="3086100"/>
+          </a:xfrm>
+        </p:spPr>
+      </p:sp>
+      <p:sp>
+        <p:nvSpPr>
+          <p:cNvPr id="3" name="Notes Placeholder 2"/>
+          <p:cNvSpPr>
+            <a:spLocks noGrp="1"/>
+          </p:cNvSpPr>
+          <p:nvPr>
+            <p:ph type="body" idx="1"/>
+          </p:nvPr>
+        </p:nvSpPr>
+        <p:spPr/>
+        <p:txBody>
+          <a:bodyPr/>
+          <a:lstStyle/>
+          <a:p>
+            <a:endParaRPr lang="en-US" dirty="0"/>
+          </a:p>
+        </p:txBody>
+      </p:sp>
+      <p:sp>
+        <p:nvSpPr>
+          <p:cNvPr id="4" name="Slide Number Placeholder 3"/>
+          <p:cNvSpPr>
+            <a:spLocks noGrp="1"/>
+          </p:cNvSpPr>
+          <p:nvPr>
+            <p:ph type="sldNum" sz="quarter" idx="5"/>
+          </p:nvPr>
+        </p:nvSpPr>
+        <p:spPr/>
+        <p:txBody>
+          <a:bodyPr/>
+          <a:lstStyle/>
+          <a:p>
+            <a:fld id="{A9F1744F-328C-BA41-8F0F-E2D4BC00C289}" type="slidenum">
+              <a:rPr lang="en-US" smtClean="0"/>
+              <a:t>2</a:t>
+            </a:fld>
+            <a:endParaRPr lang="en-US"/>
+          </a:p>
+        </p:txBody>
+      </p:sp>
+    </p:spTree>
+    <p:extLst>
+      <p:ext uri="{BB962C8B-B14F-4D97-AF65-F5344CB8AC3E}">
         <p14:creationId xmlns:p14="http://schemas.microsoft.com/office/powerpoint/2010/main" val="3774704561"/>
       </p:ext>
     </p:extLst>
@@ -750,7 +895,7 @@
           <a:p>
             <a:fld id="{A594FCF3-F2F1-BB4C-82ED-E0D01773818E}" type="datetimeFigureOut">
               <a:rPr lang="en-US" smtClean="0"/>
-              <a:t>9/20/19</a:t>
+              <a:t>9/19/19</a:t>
             </a:fld>
             <a:endParaRPr lang="en-US"/>
           </a:p>
@@ -920,7 +1065,7 @@
           <a:p>
             <a:fld id="{A594FCF3-F2F1-BB4C-82ED-E0D01773818E}" type="datetimeFigureOut">
               <a:rPr lang="en-US" smtClean="0"/>
-              <a:t>9/20/19</a:t>
+              <a:t>9/19/19</a:t>
             </a:fld>
             <a:endParaRPr lang="en-US"/>
           </a:p>
@@ -1100,7 +1245,7 @@
           <a:p>
             <a:fld id="{A594FCF3-F2F1-BB4C-82ED-E0D01773818E}" type="datetimeFigureOut">
               <a:rPr lang="en-US" smtClean="0"/>
-              <a:t>9/20/19</a:t>
+              <a:t>9/19/19</a:t>
             </a:fld>
             <a:endParaRPr lang="en-US"/>
           </a:p>
@@ -1270,7 +1415,7 @@
           <a:p>
             <a:fld id="{A594FCF3-F2F1-BB4C-82ED-E0D01773818E}" type="datetimeFigureOut">
               <a:rPr lang="en-US" smtClean="0"/>
-              <a:t>9/20/19</a:t>
+              <a:t>9/19/19</a:t>
             </a:fld>
             <a:endParaRPr lang="en-US"/>
           </a:p>
@@ -1516,7 +1661,7 @@
           <a:p>
             <a:fld id="{A594FCF3-F2F1-BB4C-82ED-E0D01773818E}" type="datetimeFigureOut">
               <a:rPr lang="en-US" smtClean="0"/>
-              <a:t>9/20/19</a:t>
+              <a:t>9/19/19</a:t>
             </a:fld>
             <a:endParaRPr lang="en-US"/>
           </a:p>
@@ -1748,7 +1893,7 @@
           <a:p>
             <a:fld id="{A594FCF3-F2F1-BB4C-82ED-E0D01773818E}" type="datetimeFigureOut">
               <a:rPr lang="en-US" smtClean="0"/>
-              <a:t>9/20/19</a:t>
+              <a:t>9/19/19</a:t>
             </a:fld>
             <a:endParaRPr lang="en-US"/>
           </a:p>
@@ -2115,7 +2260,7 @@
           <a:p>
             <a:fld id="{A594FCF3-F2F1-BB4C-82ED-E0D01773818E}" type="datetimeFigureOut">
               <a:rPr lang="en-US" smtClean="0"/>
-              <a:t>9/20/19</a:t>
+              <a:t>9/19/19</a:t>
             </a:fld>
             <a:endParaRPr lang="en-US"/>
           </a:p>
@@ -2233,7 +2378,7 @@
           <a:p>
             <a:fld id="{A594FCF3-F2F1-BB4C-82ED-E0D01773818E}" type="datetimeFigureOut">
               <a:rPr lang="en-US" smtClean="0"/>
-              <a:t>9/20/19</a:t>
+              <a:t>9/19/19</a:t>
             </a:fld>
             <a:endParaRPr lang="en-US"/>
           </a:p>
@@ -2328,7 +2473,7 @@
           <a:p>
             <a:fld id="{A594FCF3-F2F1-BB4C-82ED-E0D01773818E}" type="datetimeFigureOut">
               <a:rPr lang="en-US" smtClean="0"/>
-              <a:t>9/20/19</a:t>
+              <a:t>9/19/19</a:t>
             </a:fld>
             <a:endParaRPr lang="en-US"/>
           </a:p>
@@ -2605,7 +2750,7 @@
           <a:p>
             <a:fld id="{A594FCF3-F2F1-BB4C-82ED-E0D01773818E}" type="datetimeFigureOut">
               <a:rPr lang="en-US" smtClean="0"/>
-              <a:t>9/20/19</a:t>
+              <a:t>9/19/19</a:t>
             </a:fld>
             <a:endParaRPr lang="en-US"/>
           </a:p>
@@ -2862,7 +3007,7 @@
           <a:p>
             <a:fld id="{A594FCF3-F2F1-BB4C-82ED-E0D01773818E}" type="datetimeFigureOut">
               <a:rPr lang="en-US" smtClean="0"/>
-              <a:t>9/20/19</a:t>
+              <a:t>9/19/19</a:t>
             </a:fld>
             <a:endParaRPr lang="en-US"/>
           </a:p>
@@ -3075,7 +3220,7 @@
           <a:p>
             <a:fld id="{A594FCF3-F2F1-BB4C-82ED-E0D01773818E}" type="datetimeFigureOut">
               <a:rPr lang="en-US" smtClean="0"/>
-              <a:t>9/20/19</a:t>
+              <a:t>9/19/19</a:t>
             </a:fld>
             <a:endParaRPr lang="en-US"/>
           </a:p>
@@ -3464,6 +3609,2531 @@
 </file>
 
 <file path=ppt/slides/slide1.xml><?xml version="1.0" encoding="utf-8"?>
+<p:sld xmlns:a="http://schemas.openxmlformats.org/drawingml/2006/main" xmlns:r="http://schemas.openxmlformats.org/officeDocument/2006/relationships" xmlns:p="http://schemas.openxmlformats.org/presentationml/2006/main" show="0">
+  <p:cSld>
+    <p:spTree>
+      <p:nvGrpSpPr>
+        <p:cNvPr id="1" name=""/>
+        <p:cNvGrpSpPr/>
+        <p:nvPr/>
+      </p:nvGrpSpPr>
+      <p:grpSpPr>
+        <a:xfrm>
+          <a:off x="0" y="0"/>
+          <a:ext cx="0" cy="0"/>
+          <a:chOff x="0" y="0"/>
+          <a:chExt cx="0" cy="0"/>
+        </a:xfrm>
+      </p:grpSpPr>
+      <p:pic>
+        <p:nvPicPr>
+          <p:cNvPr id="6" name="Picture 5" descr="A close up of a coral&#10;&#10;Description automatically generated">
+            <a:extLst>
+              <a:ext uri="{FF2B5EF4-FFF2-40B4-BE49-F238E27FC236}">
+                <a16:creationId xmlns:a16="http://schemas.microsoft.com/office/drawing/2014/main" id="{18BCA4B9-4112-0640-A084-9D1E6A72D67D}"/>
+              </a:ext>
+            </a:extLst>
+          </p:cNvPr>
+          <p:cNvPicPr>
+            <a:picLocks noChangeAspect="1"/>
+          </p:cNvPicPr>
+          <p:nvPr/>
+        </p:nvPicPr>
+        <p:blipFill>
+          <a:blip r:embed="rId3"/>
+          <a:stretch>
+            <a:fillRect/>
+          </a:stretch>
+        </p:blipFill>
+        <p:spPr>
+          <a:xfrm>
+            <a:off x="-272827" y="98313"/>
+            <a:ext cx="2696588" cy="2683105"/>
+          </a:xfrm>
+          <a:prstGeom prst="rect">
+            <a:avLst/>
+          </a:prstGeom>
+        </p:spPr>
+      </p:pic>
+      <mc:AlternateContent xmlns:mc="http://schemas.openxmlformats.org/markup-compatibility/2006">
+        <mc:Choice xmlns:p14="http://schemas.microsoft.com/office/powerpoint/2010/main" Requires="p14">
+          <p:contentPart p14:bwMode="auto" r:id="rId4">
+            <p14:nvContentPartPr>
+              <p14:cNvPr id="30" name="Ink 29">
+                <a:extLst>
+                  <a:ext uri="{FF2B5EF4-FFF2-40B4-BE49-F238E27FC236}">
+                    <a16:creationId xmlns:a16="http://schemas.microsoft.com/office/drawing/2014/main" id="{8BD33D62-86EE-4A43-9565-C472D869CA54}"/>
+                  </a:ext>
+                </a:extLst>
+              </p14:cNvPr>
+              <p14:cNvContentPartPr/>
+              <p14:nvPr/>
+            </p14:nvContentPartPr>
+            <p14:xfrm>
+              <a:off x="-2131089" y="-720549"/>
+              <a:ext cx="360" cy="360"/>
+            </p14:xfrm>
+          </p:contentPart>
+        </mc:Choice>
+        <mc:Fallback>
+          <p:pic>
+            <p:nvPicPr>
+              <p:cNvPr id="30" name="Ink 29">
+                <a:extLst>
+                  <a:ext uri="{FF2B5EF4-FFF2-40B4-BE49-F238E27FC236}">
+                    <a16:creationId xmlns:a16="http://schemas.microsoft.com/office/drawing/2014/main" id="{8BD33D62-86EE-4A43-9565-C472D869CA54}"/>
+                  </a:ext>
+                </a:extLst>
+              </p:cNvPr>
+              <p:cNvPicPr/>
+              <p:nvPr/>
+            </p:nvPicPr>
+            <p:blipFill>
+              <a:blip r:embed="rId5"/>
+              <a:stretch>
+                <a:fillRect/>
+              </a:stretch>
+            </p:blipFill>
+            <p:spPr>
+              <a:xfrm>
+                <a:off x="-2167089" y="-756549"/>
+                <a:ext cx="72000" cy="72000"/>
+              </a:xfrm>
+              <a:prstGeom prst="rect">
+                <a:avLst/>
+              </a:prstGeom>
+            </p:spPr>
+          </p:pic>
+        </mc:Fallback>
+      </mc:AlternateContent>
+      <p:grpSp>
+        <p:nvGrpSpPr>
+          <p:cNvPr id="2" name="Group 1">
+            <a:extLst>
+              <a:ext uri="{FF2B5EF4-FFF2-40B4-BE49-F238E27FC236}">
+                <a16:creationId xmlns:a16="http://schemas.microsoft.com/office/drawing/2014/main" id="{C07A61DD-9D23-6949-BF39-4E526B7E421C}"/>
+              </a:ext>
+            </a:extLst>
+          </p:cNvPr>
+          <p:cNvGrpSpPr/>
+          <p:nvPr/>
+        </p:nvGrpSpPr>
+        <p:grpSpPr>
+          <a:xfrm>
+            <a:off x="2658544" y="624544"/>
+            <a:ext cx="3027085" cy="1880716"/>
+            <a:chOff x="3893311" y="1106906"/>
+            <a:chExt cx="3537549" cy="2197867"/>
+          </a:xfrm>
+        </p:grpSpPr>
+        <mc:AlternateContent xmlns:mc="http://schemas.openxmlformats.org/markup-compatibility/2006" xmlns:p14="http://schemas.microsoft.com/office/powerpoint/2010/main">
+          <mc:Choice Requires="p14">
+            <p:contentPart p14:bwMode="auto" r:id="rId6">
+              <p14:nvContentPartPr>
+                <p14:cNvPr id="38" name="Ink 37">
+                  <a:extLst>
+                    <a:ext uri="{FF2B5EF4-FFF2-40B4-BE49-F238E27FC236}">
+                      <a16:creationId xmlns:a16="http://schemas.microsoft.com/office/drawing/2014/main" id="{F7DD3F0F-DC3E-F943-949D-23ACA30C61F4}"/>
+                    </a:ext>
+                  </a:extLst>
+                </p14:cNvPr>
+                <p14:cNvContentPartPr/>
+                <p14:nvPr/>
+              </p14:nvContentPartPr>
+              <p14:xfrm>
+                <a:off x="4143600" y="1106906"/>
+                <a:ext cx="2830445" cy="1937084"/>
+              </p14:xfrm>
+            </p:contentPart>
+          </mc:Choice>
+          <mc:Fallback xmlns="">
+            <p:pic>
+              <p:nvPicPr>
+                <p:cNvPr id="38" name="Ink 37">
+                  <a:extLst>
+                    <a:ext uri="{FF2B5EF4-FFF2-40B4-BE49-F238E27FC236}">
+                      <a16:creationId xmlns:a16="http://schemas.microsoft.com/office/drawing/2014/main" id="{F7DD3F0F-DC3E-F943-949D-23ACA30C61F4}"/>
+                    </a:ext>
+                  </a:extLst>
+                </p:cNvPr>
+                <p:cNvPicPr/>
+                <p:nvPr/>
+              </p:nvPicPr>
+              <p:blipFill>
+                <a:blip r:embed="rId7"/>
+                <a:stretch>
+                  <a:fillRect/>
+                </a:stretch>
+              </p:blipFill>
+              <p:spPr>
+                <a:xfrm>
+                  <a:off x="4071672" y="1034975"/>
+                  <a:ext cx="2973881" cy="2080946"/>
+                </a:xfrm>
+                <a:prstGeom prst="rect">
+                  <a:avLst/>
+                </a:prstGeom>
+              </p:spPr>
+            </p:pic>
+          </mc:Fallback>
+        </mc:AlternateContent>
+        <p:grpSp>
+          <p:nvGrpSpPr>
+            <p:cNvPr id="45" name="Group 44">
+              <a:extLst>
+                <a:ext uri="{FF2B5EF4-FFF2-40B4-BE49-F238E27FC236}">
+                  <a16:creationId xmlns:a16="http://schemas.microsoft.com/office/drawing/2014/main" id="{24644915-0F54-794F-A944-B19D115CE063}"/>
+                </a:ext>
+              </a:extLst>
+            </p:cNvPr>
+            <p:cNvGrpSpPr/>
+            <p:nvPr/>
+          </p:nvGrpSpPr>
+          <p:grpSpPr>
+            <a:xfrm rot="19027459">
+              <a:off x="5048564" y="2367424"/>
+              <a:ext cx="304854" cy="299474"/>
+              <a:chOff x="5775952" y="3118068"/>
+              <a:chExt cx="316518" cy="310932"/>
+            </a:xfrm>
+          </p:grpSpPr>
+          <p:sp>
+            <p:nvSpPr>
+              <p:cNvPr id="41" name="Rounded Rectangle 40">
+                <a:extLst>
+                  <a:ext uri="{FF2B5EF4-FFF2-40B4-BE49-F238E27FC236}">
+                    <a16:creationId xmlns:a16="http://schemas.microsoft.com/office/drawing/2014/main" id="{847B7786-EBEA-A44A-B610-8B87FD39279C}"/>
+                  </a:ext>
+                </a:extLst>
+              </p:cNvPr>
+              <p:cNvSpPr/>
+              <p:nvPr/>
+            </p:nvSpPr>
+            <p:spPr>
+              <a:xfrm>
+                <a:off x="5775952" y="3118068"/>
+                <a:ext cx="159227" cy="310932"/>
+              </a:xfrm>
+              <a:prstGeom prst="roundRect">
+                <a:avLst/>
+              </a:prstGeom>
+              <a:solidFill>
+                <a:srgbClr val="DED59B"/>
+              </a:solidFill>
+              <a:ln>
+                <a:noFill/>
+              </a:ln>
+            </p:spPr>
+            <p:style>
+              <a:lnRef idx="2">
+                <a:schemeClr val="accent1">
+                  <a:shade val="50000"/>
+                </a:schemeClr>
+              </a:lnRef>
+              <a:fillRef idx="1">
+                <a:schemeClr val="accent1"/>
+              </a:fillRef>
+              <a:effectRef idx="0">
+                <a:schemeClr val="accent1"/>
+              </a:effectRef>
+              <a:fontRef idx="minor">
+                <a:schemeClr val="lt1"/>
+              </a:fontRef>
+            </p:style>
+            <p:txBody>
+              <a:bodyPr rtlCol="0" anchor="ctr"/>
+              <a:lstStyle/>
+              <a:p>
+                <a:pPr algn="ctr"/>
+                <a:endParaRPr lang="en-US" dirty="0"/>
+              </a:p>
+            </p:txBody>
+          </p:sp>
+          <p:sp>
+            <p:nvSpPr>
+              <p:cNvPr id="44" name="Rounded Rectangle 43">
+                <a:extLst>
+                  <a:ext uri="{FF2B5EF4-FFF2-40B4-BE49-F238E27FC236}">
+                    <a16:creationId xmlns:a16="http://schemas.microsoft.com/office/drawing/2014/main" id="{363A9FF8-6F9C-644F-BF7B-3CF762CD4ADE}"/>
+                  </a:ext>
+                </a:extLst>
+              </p:cNvPr>
+              <p:cNvSpPr/>
+              <p:nvPr/>
+            </p:nvSpPr>
+            <p:spPr>
+              <a:xfrm>
+                <a:off x="5933243" y="3118068"/>
+                <a:ext cx="159227" cy="310932"/>
+              </a:xfrm>
+              <a:prstGeom prst="roundRect">
+                <a:avLst/>
+              </a:prstGeom>
+              <a:solidFill>
+                <a:srgbClr val="4A69AF"/>
+              </a:solidFill>
+              <a:ln>
+                <a:noFill/>
+              </a:ln>
+            </p:spPr>
+            <p:style>
+              <a:lnRef idx="2">
+                <a:schemeClr val="accent1">
+                  <a:shade val="50000"/>
+                </a:schemeClr>
+              </a:lnRef>
+              <a:fillRef idx="1">
+                <a:schemeClr val="accent1"/>
+              </a:fillRef>
+              <a:effectRef idx="0">
+                <a:schemeClr val="accent1"/>
+              </a:effectRef>
+              <a:fontRef idx="minor">
+                <a:schemeClr val="lt1"/>
+              </a:fontRef>
+            </p:style>
+            <p:txBody>
+              <a:bodyPr rtlCol="0" anchor="ctr"/>
+              <a:lstStyle/>
+              <a:p>
+                <a:pPr algn="ctr"/>
+                <a:endParaRPr lang="en-US"/>
+              </a:p>
+            </p:txBody>
+          </p:sp>
+        </p:grpSp>
+        <p:grpSp>
+          <p:nvGrpSpPr>
+            <p:cNvPr id="48" name="Group 47">
+              <a:extLst>
+                <a:ext uri="{FF2B5EF4-FFF2-40B4-BE49-F238E27FC236}">
+                  <a16:creationId xmlns:a16="http://schemas.microsoft.com/office/drawing/2014/main" id="{46B3BA81-EC63-2148-97D0-C6AD93B20366}"/>
+                </a:ext>
+              </a:extLst>
+            </p:cNvPr>
+            <p:cNvGrpSpPr/>
+            <p:nvPr/>
+          </p:nvGrpSpPr>
+          <p:grpSpPr>
+            <a:xfrm rot="780047">
+              <a:off x="5444356" y="2050901"/>
+              <a:ext cx="304854" cy="299474"/>
+              <a:chOff x="5775952" y="3118068"/>
+              <a:chExt cx="316518" cy="310932"/>
+            </a:xfrm>
+          </p:grpSpPr>
+          <p:sp>
+            <p:nvSpPr>
+              <p:cNvPr id="49" name="Rounded Rectangle 48">
+                <a:extLst>
+                  <a:ext uri="{FF2B5EF4-FFF2-40B4-BE49-F238E27FC236}">
+                    <a16:creationId xmlns:a16="http://schemas.microsoft.com/office/drawing/2014/main" id="{E7EDAC24-E25F-A24D-A716-418A44EFD674}"/>
+                  </a:ext>
+                </a:extLst>
+              </p:cNvPr>
+              <p:cNvSpPr/>
+              <p:nvPr/>
+            </p:nvSpPr>
+            <p:spPr>
+              <a:xfrm>
+                <a:off x="5775952" y="3118068"/>
+                <a:ext cx="159227" cy="310932"/>
+              </a:xfrm>
+              <a:prstGeom prst="roundRect">
+                <a:avLst/>
+              </a:prstGeom>
+              <a:solidFill>
+                <a:srgbClr val="6BD9ED"/>
+              </a:solidFill>
+              <a:ln>
+                <a:noFill/>
+              </a:ln>
+            </p:spPr>
+            <p:style>
+              <a:lnRef idx="2">
+                <a:schemeClr val="accent1">
+                  <a:shade val="50000"/>
+                </a:schemeClr>
+              </a:lnRef>
+              <a:fillRef idx="1">
+                <a:schemeClr val="accent1"/>
+              </a:fillRef>
+              <a:effectRef idx="0">
+                <a:schemeClr val="accent1"/>
+              </a:effectRef>
+              <a:fontRef idx="minor">
+                <a:schemeClr val="lt1"/>
+              </a:fontRef>
+            </p:style>
+            <p:txBody>
+              <a:bodyPr rtlCol="0" anchor="ctr"/>
+              <a:lstStyle/>
+              <a:p>
+                <a:pPr algn="ctr"/>
+                <a:endParaRPr lang="en-US" dirty="0"/>
+              </a:p>
+            </p:txBody>
+          </p:sp>
+          <p:sp>
+            <p:nvSpPr>
+              <p:cNvPr id="50" name="Rounded Rectangle 49">
+                <a:extLst>
+                  <a:ext uri="{FF2B5EF4-FFF2-40B4-BE49-F238E27FC236}">
+                    <a16:creationId xmlns:a16="http://schemas.microsoft.com/office/drawing/2014/main" id="{94F8CA03-D94C-454D-8189-B230F45ABE1C}"/>
+                  </a:ext>
+                </a:extLst>
+              </p:cNvPr>
+              <p:cNvSpPr/>
+              <p:nvPr/>
+            </p:nvSpPr>
+            <p:spPr>
+              <a:xfrm>
+                <a:off x="5933243" y="3118068"/>
+                <a:ext cx="159227" cy="310932"/>
+              </a:xfrm>
+              <a:prstGeom prst="roundRect">
+                <a:avLst/>
+              </a:prstGeom>
+              <a:solidFill>
+                <a:srgbClr val="D18349"/>
+              </a:solidFill>
+              <a:ln>
+                <a:noFill/>
+              </a:ln>
+            </p:spPr>
+            <p:style>
+              <a:lnRef idx="2">
+                <a:schemeClr val="accent1">
+                  <a:shade val="50000"/>
+                </a:schemeClr>
+              </a:lnRef>
+              <a:fillRef idx="1">
+                <a:schemeClr val="accent1"/>
+              </a:fillRef>
+              <a:effectRef idx="0">
+                <a:schemeClr val="accent1"/>
+              </a:effectRef>
+              <a:fontRef idx="minor">
+                <a:schemeClr val="lt1"/>
+              </a:fontRef>
+            </p:style>
+            <p:txBody>
+              <a:bodyPr rtlCol="0" anchor="ctr"/>
+              <a:lstStyle/>
+              <a:p>
+                <a:pPr algn="ctr"/>
+                <a:endParaRPr lang="en-US"/>
+              </a:p>
+            </p:txBody>
+          </p:sp>
+        </p:grpSp>
+        <p:grpSp>
+          <p:nvGrpSpPr>
+            <p:cNvPr id="51" name="Group 50">
+              <a:extLst>
+                <a:ext uri="{FF2B5EF4-FFF2-40B4-BE49-F238E27FC236}">
+                  <a16:creationId xmlns:a16="http://schemas.microsoft.com/office/drawing/2014/main" id="{C11095B2-2422-7748-8F9D-2495722DE5AF}"/>
+                </a:ext>
+              </a:extLst>
+            </p:cNvPr>
+            <p:cNvGrpSpPr/>
+            <p:nvPr/>
+          </p:nvGrpSpPr>
+          <p:grpSpPr>
+            <a:xfrm rot="4009933">
+              <a:off x="6268679" y="1753564"/>
+              <a:ext cx="304854" cy="299474"/>
+              <a:chOff x="5775952" y="3118068"/>
+              <a:chExt cx="316518" cy="310932"/>
+            </a:xfrm>
+          </p:grpSpPr>
+          <p:sp>
+            <p:nvSpPr>
+              <p:cNvPr id="52" name="Rounded Rectangle 51">
+                <a:extLst>
+                  <a:ext uri="{FF2B5EF4-FFF2-40B4-BE49-F238E27FC236}">
+                    <a16:creationId xmlns:a16="http://schemas.microsoft.com/office/drawing/2014/main" id="{DC09565D-F1CD-884E-9B5F-18B24682650A}"/>
+                  </a:ext>
+                </a:extLst>
+              </p:cNvPr>
+              <p:cNvSpPr/>
+              <p:nvPr/>
+            </p:nvSpPr>
+            <p:spPr>
+              <a:xfrm>
+                <a:off x="5775952" y="3118068"/>
+                <a:ext cx="159227" cy="310932"/>
+              </a:xfrm>
+              <a:prstGeom prst="roundRect">
+                <a:avLst/>
+              </a:prstGeom>
+              <a:solidFill>
+                <a:srgbClr val="860138"/>
+              </a:solidFill>
+              <a:ln>
+                <a:noFill/>
+              </a:ln>
+            </p:spPr>
+            <p:style>
+              <a:lnRef idx="2">
+                <a:schemeClr val="accent1">
+                  <a:shade val="50000"/>
+                </a:schemeClr>
+              </a:lnRef>
+              <a:fillRef idx="1">
+                <a:schemeClr val="accent1"/>
+              </a:fillRef>
+              <a:effectRef idx="0">
+                <a:schemeClr val="accent1"/>
+              </a:effectRef>
+              <a:fontRef idx="minor">
+                <a:schemeClr val="lt1"/>
+              </a:fontRef>
+            </p:style>
+            <p:txBody>
+              <a:bodyPr rtlCol="0" anchor="ctr"/>
+              <a:lstStyle/>
+              <a:p>
+                <a:pPr algn="ctr"/>
+                <a:endParaRPr lang="en-US" dirty="0"/>
+              </a:p>
+            </p:txBody>
+          </p:sp>
+          <p:sp>
+            <p:nvSpPr>
+              <p:cNvPr id="53" name="Rounded Rectangle 52">
+                <a:extLst>
+                  <a:ext uri="{FF2B5EF4-FFF2-40B4-BE49-F238E27FC236}">
+                    <a16:creationId xmlns:a16="http://schemas.microsoft.com/office/drawing/2014/main" id="{AF8195C6-9E88-8C4D-9CF7-159DB8C69D41}"/>
+                  </a:ext>
+                </a:extLst>
+              </p:cNvPr>
+              <p:cNvSpPr/>
+              <p:nvPr/>
+            </p:nvSpPr>
+            <p:spPr>
+              <a:xfrm>
+                <a:off x="5933243" y="3118068"/>
+                <a:ext cx="159227" cy="310932"/>
+              </a:xfrm>
+              <a:prstGeom prst="roundRect">
+                <a:avLst/>
+              </a:prstGeom>
+              <a:solidFill>
+                <a:srgbClr val="6FBB98"/>
+              </a:solidFill>
+              <a:ln>
+                <a:noFill/>
+              </a:ln>
+            </p:spPr>
+            <p:style>
+              <a:lnRef idx="2">
+                <a:schemeClr val="accent1">
+                  <a:shade val="50000"/>
+                </a:schemeClr>
+              </a:lnRef>
+              <a:fillRef idx="1">
+                <a:schemeClr val="accent1"/>
+              </a:fillRef>
+              <a:effectRef idx="0">
+                <a:schemeClr val="accent1"/>
+              </a:effectRef>
+              <a:fontRef idx="minor">
+                <a:schemeClr val="lt1"/>
+              </a:fontRef>
+            </p:style>
+            <p:txBody>
+              <a:bodyPr rtlCol="0" anchor="ctr"/>
+              <a:lstStyle/>
+              <a:p>
+                <a:pPr algn="ctr"/>
+                <a:endParaRPr lang="en-US"/>
+              </a:p>
+            </p:txBody>
+          </p:sp>
+        </p:grpSp>
+        <p:sp>
+          <p:nvSpPr>
+            <p:cNvPr id="83" name="TextBox 82">
+              <a:extLst>
+                <a:ext uri="{FF2B5EF4-FFF2-40B4-BE49-F238E27FC236}">
+                  <a16:creationId xmlns:a16="http://schemas.microsoft.com/office/drawing/2014/main" id="{167164D5-945D-C341-B028-6479A84D0192}"/>
+                </a:ext>
+              </a:extLst>
+            </p:cNvPr>
+            <p:cNvSpPr txBox="1"/>
+            <p:nvPr/>
+          </p:nvSpPr>
+          <p:spPr>
+            <a:xfrm>
+              <a:off x="3893311" y="2837191"/>
+              <a:ext cx="1213853" cy="467582"/>
+            </a:xfrm>
+            <a:prstGeom prst="rect">
+              <a:avLst/>
+            </a:prstGeom>
+            <a:noFill/>
+          </p:spPr>
+          <p:txBody>
+            <a:bodyPr wrap="square" rtlCol="0">
+              <a:spAutoFit/>
+            </a:bodyPr>
+            <a:lstStyle/>
+            <a:p>
+              <a:pPr algn="r"/>
+              <a:r>
+                <a:rPr lang="en-US" sz="1000" b="1" dirty="0">
+                  <a:solidFill>
+                    <a:schemeClr val="accent5">
+                      <a:lumMod val="75000"/>
+                    </a:schemeClr>
+                  </a:solidFill>
+                  <a:latin typeface="Arial" panose="020B0604020202020204" pitchFamily="34" charset="0"/>
+                  <a:cs typeface="Arial" panose="020B0604020202020204" pitchFamily="34" charset="0"/>
+                </a:rPr>
+                <a:t>genomic </a:t>
+              </a:r>
+            </a:p>
+            <a:p>
+              <a:pPr algn="r"/>
+              <a:r>
+                <a:rPr lang="en-US" sz="1000" b="1" dirty="0">
+                  <a:solidFill>
+                    <a:schemeClr val="accent5">
+                      <a:lumMod val="75000"/>
+                    </a:schemeClr>
+                  </a:solidFill>
+                  <a:latin typeface="Arial" panose="020B0604020202020204" pitchFamily="34" charset="0"/>
+                  <a:cs typeface="Arial" panose="020B0604020202020204" pitchFamily="34" charset="0"/>
+                </a:rPr>
+                <a:t>start</a:t>
+              </a:r>
+            </a:p>
+          </p:txBody>
+        </p:sp>
+        <p:sp>
+          <p:nvSpPr>
+            <p:cNvPr id="43" name="TextBox 42">
+              <a:extLst>
+                <a:ext uri="{FF2B5EF4-FFF2-40B4-BE49-F238E27FC236}">
+                  <a16:creationId xmlns:a16="http://schemas.microsoft.com/office/drawing/2014/main" id="{2A72AAF0-68F6-3D44-A76A-CA3312FC3656}"/>
+                </a:ext>
+              </a:extLst>
+            </p:cNvPr>
+            <p:cNvSpPr txBox="1"/>
+            <p:nvPr/>
+          </p:nvSpPr>
+          <p:spPr>
+            <a:xfrm>
+              <a:off x="6526724" y="2217679"/>
+              <a:ext cx="904136" cy="467582"/>
+            </a:xfrm>
+            <a:prstGeom prst="rect">
+              <a:avLst/>
+            </a:prstGeom>
+            <a:noFill/>
+          </p:spPr>
+          <p:txBody>
+            <a:bodyPr wrap="square" rtlCol="0">
+              <a:spAutoFit/>
+            </a:bodyPr>
+            <a:lstStyle/>
+            <a:p>
+              <a:pPr algn="ctr"/>
+              <a:r>
+                <a:rPr lang="en-US" sz="1000" b="1" dirty="0">
+                  <a:solidFill>
+                    <a:schemeClr val="accent5">
+                      <a:lumMod val="75000"/>
+                    </a:schemeClr>
+                  </a:solidFill>
+                  <a:latin typeface="Arial" panose="020B0604020202020204" pitchFamily="34" charset="0"/>
+                  <a:cs typeface="Arial" panose="020B0604020202020204" pitchFamily="34" charset="0"/>
+                </a:rPr>
+                <a:t>genomic end</a:t>
+              </a:r>
+            </a:p>
+          </p:txBody>
+        </p:sp>
+      </p:grpSp>
+      <p:grpSp>
+        <p:nvGrpSpPr>
+          <p:cNvPr id="7" name="Group 6">
+            <a:extLst>
+              <a:ext uri="{FF2B5EF4-FFF2-40B4-BE49-F238E27FC236}">
+                <a16:creationId xmlns:a16="http://schemas.microsoft.com/office/drawing/2014/main" id="{8166C904-4F5F-FE4E-8B0B-D846257D3E9A}"/>
+              </a:ext>
+            </a:extLst>
+          </p:cNvPr>
+          <p:cNvGrpSpPr/>
+          <p:nvPr/>
+        </p:nvGrpSpPr>
+        <p:grpSpPr>
+          <a:xfrm>
+            <a:off x="6165726" y="624544"/>
+            <a:ext cx="4108929" cy="1818076"/>
+            <a:chOff x="1134106" y="4239056"/>
+            <a:chExt cx="4108929" cy="1818076"/>
+          </a:xfrm>
+        </p:grpSpPr>
+        <p:grpSp>
+          <p:nvGrpSpPr>
+            <p:cNvPr id="69" name="Group 68">
+              <a:extLst>
+                <a:ext uri="{FF2B5EF4-FFF2-40B4-BE49-F238E27FC236}">
+                  <a16:creationId xmlns:a16="http://schemas.microsoft.com/office/drawing/2014/main" id="{19FFB7A7-54D9-3943-870E-436DC3343D7C}"/>
+                </a:ext>
+              </a:extLst>
+            </p:cNvPr>
+            <p:cNvGrpSpPr/>
+            <p:nvPr/>
+          </p:nvGrpSpPr>
+          <p:grpSpPr>
+            <a:xfrm>
+              <a:off x="1240735" y="4762367"/>
+              <a:ext cx="304854" cy="299474"/>
+              <a:chOff x="5775952" y="3118068"/>
+              <a:chExt cx="316518" cy="310932"/>
+            </a:xfrm>
+          </p:grpSpPr>
+          <p:sp>
+            <p:nvSpPr>
+              <p:cNvPr id="70" name="Rounded Rectangle 69">
+                <a:extLst>
+                  <a:ext uri="{FF2B5EF4-FFF2-40B4-BE49-F238E27FC236}">
+                    <a16:creationId xmlns:a16="http://schemas.microsoft.com/office/drawing/2014/main" id="{5A58217C-198D-5649-8066-E7BB7E1E94D2}"/>
+                  </a:ext>
+                </a:extLst>
+              </p:cNvPr>
+              <p:cNvSpPr/>
+              <p:nvPr/>
+            </p:nvSpPr>
+            <p:spPr>
+              <a:xfrm>
+                <a:off x="5775952" y="3118068"/>
+                <a:ext cx="159227" cy="310932"/>
+              </a:xfrm>
+              <a:prstGeom prst="roundRect">
+                <a:avLst/>
+              </a:prstGeom>
+              <a:solidFill>
+                <a:srgbClr val="DED59B"/>
+              </a:solidFill>
+              <a:ln>
+                <a:noFill/>
+              </a:ln>
+            </p:spPr>
+            <p:style>
+              <a:lnRef idx="2">
+                <a:schemeClr val="accent1">
+                  <a:shade val="50000"/>
+                </a:schemeClr>
+              </a:lnRef>
+              <a:fillRef idx="1">
+                <a:schemeClr val="accent1"/>
+              </a:fillRef>
+              <a:effectRef idx="0">
+                <a:schemeClr val="accent1"/>
+              </a:effectRef>
+              <a:fontRef idx="minor">
+                <a:schemeClr val="lt1"/>
+              </a:fontRef>
+            </p:style>
+            <p:txBody>
+              <a:bodyPr rtlCol="0" anchor="ctr"/>
+              <a:lstStyle/>
+              <a:p>
+                <a:pPr algn="ctr"/>
+                <a:endParaRPr lang="en-US" dirty="0"/>
+              </a:p>
+            </p:txBody>
+          </p:sp>
+          <p:sp>
+            <p:nvSpPr>
+              <p:cNvPr id="71" name="Rounded Rectangle 70">
+                <a:extLst>
+                  <a:ext uri="{FF2B5EF4-FFF2-40B4-BE49-F238E27FC236}">
+                    <a16:creationId xmlns:a16="http://schemas.microsoft.com/office/drawing/2014/main" id="{345BC1FE-74C3-0547-95B4-2D753E496BA4}"/>
+                  </a:ext>
+                </a:extLst>
+              </p:cNvPr>
+              <p:cNvSpPr/>
+              <p:nvPr/>
+            </p:nvSpPr>
+            <p:spPr>
+              <a:xfrm>
+                <a:off x="5933243" y="3118068"/>
+                <a:ext cx="159227" cy="310932"/>
+              </a:xfrm>
+              <a:prstGeom prst="roundRect">
+                <a:avLst/>
+              </a:prstGeom>
+              <a:solidFill>
+                <a:srgbClr val="4A69AF"/>
+              </a:solidFill>
+              <a:ln>
+                <a:noFill/>
+              </a:ln>
+            </p:spPr>
+            <p:style>
+              <a:lnRef idx="2">
+                <a:schemeClr val="accent1">
+                  <a:shade val="50000"/>
+                </a:schemeClr>
+              </a:lnRef>
+              <a:fillRef idx="1">
+                <a:schemeClr val="accent1"/>
+              </a:fillRef>
+              <a:effectRef idx="0">
+                <a:schemeClr val="accent1"/>
+              </a:effectRef>
+              <a:fontRef idx="minor">
+                <a:schemeClr val="lt1"/>
+              </a:fontRef>
+            </p:style>
+            <p:txBody>
+              <a:bodyPr rtlCol="0" anchor="ctr"/>
+              <a:lstStyle/>
+              <a:p>
+                <a:pPr algn="ctr"/>
+                <a:endParaRPr lang="en-US"/>
+              </a:p>
+            </p:txBody>
+          </p:sp>
+        </p:grpSp>
+        <p:grpSp>
+          <p:nvGrpSpPr>
+            <p:cNvPr id="72" name="Group 71">
+              <a:extLst>
+                <a:ext uri="{FF2B5EF4-FFF2-40B4-BE49-F238E27FC236}">
+                  <a16:creationId xmlns:a16="http://schemas.microsoft.com/office/drawing/2014/main" id="{90A4CCFA-2968-1B4E-AF36-C42876457BB3}"/>
+                </a:ext>
+              </a:extLst>
+            </p:cNvPr>
+            <p:cNvGrpSpPr/>
+            <p:nvPr/>
+          </p:nvGrpSpPr>
+          <p:grpSpPr>
+            <a:xfrm>
+              <a:off x="1239803" y="5126496"/>
+              <a:ext cx="304854" cy="299474"/>
+              <a:chOff x="5775952" y="3118068"/>
+              <a:chExt cx="316518" cy="310932"/>
+            </a:xfrm>
+          </p:grpSpPr>
+          <p:sp>
+            <p:nvSpPr>
+              <p:cNvPr id="73" name="Rounded Rectangle 72">
+                <a:extLst>
+                  <a:ext uri="{FF2B5EF4-FFF2-40B4-BE49-F238E27FC236}">
+                    <a16:creationId xmlns:a16="http://schemas.microsoft.com/office/drawing/2014/main" id="{1284038F-DC42-B147-ACC7-5D867D20A360}"/>
+                  </a:ext>
+                </a:extLst>
+              </p:cNvPr>
+              <p:cNvSpPr/>
+              <p:nvPr/>
+            </p:nvSpPr>
+            <p:spPr>
+              <a:xfrm>
+                <a:off x="5775952" y="3118068"/>
+                <a:ext cx="159227" cy="310932"/>
+              </a:xfrm>
+              <a:prstGeom prst="roundRect">
+                <a:avLst/>
+              </a:prstGeom>
+              <a:solidFill>
+                <a:srgbClr val="6BD9ED"/>
+              </a:solidFill>
+              <a:ln>
+                <a:noFill/>
+              </a:ln>
+            </p:spPr>
+            <p:style>
+              <a:lnRef idx="2">
+                <a:schemeClr val="accent1">
+                  <a:shade val="50000"/>
+                </a:schemeClr>
+              </a:lnRef>
+              <a:fillRef idx="1">
+                <a:schemeClr val="accent1"/>
+              </a:fillRef>
+              <a:effectRef idx="0">
+                <a:schemeClr val="accent1"/>
+              </a:effectRef>
+              <a:fontRef idx="minor">
+                <a:schemeClr val="lt1"/>
+              </a:fontRef>
+            </p:style>
+            <p:txBody>
+              <a:bodyPr rtlCol="0" anchor="ctr"/>
+              <a:lstStyle/>
+              <a:p>
+                <a:pPr algn="ctr"/>
+                <a:endParaRPr lang="en-US" dirty="0"/>
+              </a:p>
+            </p:txBody>
+          </p:sp>
+          <p:sp>
+            <p:nvSpPr>
+              <p:cNvPr id="74" name="Rounded Rectangle 73">
+                <a:extLst>
+                  <a:ext uri="{FF2B5EF4-FFF2-40B4-BE49-F238E27FC236}">
+                    <a16:creationId xmlns:a16="http://schemas.microsoft.com/office/drawing/2014/main" id="{EA290626-6A55-4542-AFEA-92368CA0A89C}"/>
+                  </a:ext>
+                </a:extLst>
+              </p:cNvPr>
+              <p:cNvSpPr/>
+              <p:nvPr/>
+            </p:nvSpPr>
+            <p:spPr>
+              <a:xfrm>
+                <a:off x="5933243" y="3118068"/>
+                <a:ext cx="159227" cy="310932"/>
+              </a:xfrm>
+              <a:prstGeom prst="roundRect">
+                <a:avLst/>
+              </a:prstGeom>
+              <a:solidFill>
+                <a:srgbClr val="D18349"/>
+              </a:solidFill>
+              <a:ln>
+                <a:noFill/>
+              </a:ln>
+            </p:spPr>
+            <p:style>
+              <a:lnRef idx="2">
+                <a:schemeClr val="accent1">
+                  <a:shade val="50000"/>
+                </a:schemeClr>
+              </a:lnRef>
+              <a:fillRef idx="1">
+                <a:schemeClr val="accent1"/>
+              </a:fillRef>
+              <a:effectRef idx="0">
+                <a:schemeClr val="accent1"/>
+              </a:effectRef>
+              <a:fontRef idx="minor">
+                <a:schemeClr val="lt1"/>
+              </a:fontRef>
+            </p:style>
+            <p:txBody>
+              <a:bodyPr rtlCol="0" anchor="ctr"/>
+              <a:lstStyle/>
+              <a:p>
+                <a:pPr algn="ctr"/>
+                <a:endParaRPr lang="en-US"/>
+              </a:p>
+            </p:txBody>
+          </p:sp>
+        </p:grpSp>
+        <p:grpSp>
+          <p:nvGrpSpPr>
+            <p:cNvPr id="75" name="Group 74">
+              <a:extLst>
+                <a:ext uri="{FF2B5EF4-FFF2-40B4-BE49-F238E27FC236}">
+                  <a16:creationId xmlns:a16="http://schemas.microsoft.com/office/drawing/2014/main" id="{FC1E25EB-F234-DF40-8283-25D8CC57E611}"/>
+                </a:ext>
+              </a:extLst>
+            </p:cNvPr>
+            <p:cNvGrpSpPr/>
+            <p:nvPr/>
+          </p:nvGrpSpPr>
+          <p:grpSpPr>
+            <a:xfrm>
+              <a:off x="1238871" y="5497689"/>
+              <a:ext cx="304854" cy="299474"/>
+              <a:chOff x="5775952" y="3118068"/>
+              <a:chExt cx="316518" cy="310932"/>
+            </a:xfrm>
+          </p:grpSpPr>
+          <p:sp>
+            <p:nvSpPr>
+              <p:cNvPr id="76" name="Rounded Rectangle 75">
+                <a:extLst>
+                  <a:ext uri="{FF2B5EF4-FFF2-40B4-BE49-F238E27FC236}">
+                    <a16:creationId xmlns:a16="http://schemas.microsoft.com/office/drawing/2014/main" id="{FC41E411-47C2-4443-9D96-041B924B1502}"/>
+                  </a:ext>
+                </a:extLst>
+              </p:cNvPr>
+              <p:cNvSpPr/>
+              <p:nvPr/>
+            </p:nvSpPr>
+            <p:spPr>
+              <a:xfrm>
+                <a:off x="5775952" y="3118068"/>
+                <a:ext cx="159227" cy="310932"/>
+              </a:xfrm>
+              <a:prstGeom prst="roundRect">
+                <a:avLst/>
+              </a:prstGeom>
+              <a:solidFill>
+                <a:srgbClr val="860138"/>
+              </a:solidFill>
+              <a:ln>
+                <a:noFill/>
+              </a:ln>
+            </p:spPr>
+            <p:style>
+              <a:lnRef idx="2">
+                <a:schemeClr val="accent1">
+                  <a:shade val="50000"/>
+                </a:schemeClr>
+              </a:lnRef>
+              <a:fillRef idx="1">
+                <a:schemeClr val="accent1"/>
+              </a:fillRef>
+              <a:effectRef idx="0">
+                <a:schemeClr val="accent1"/>
+              </a:effectRef>
+              <a:fontRef idx="minor">
+                <a:schemeClr val="lt1"/>
+              </a:fontRef>
+            </p:style>
+            <p:txBody>
+              <a:bodyPr rtlCol="0" anchor="ctr"/>
+              <a:lstStyle/>
+              <a:p>
+                <a:pPr algn="ctr"/>
+                <a:endParaRPr lang="en-US" dirty="0"/>
+              </a:p>
+            </p:txBody>
+          </p:sp>
+          <p:sp>
+            <p:nvSpPr>
+              <p:cNvPr id="77" name="Rounded Rectangle 76">
+                <a:extLst>
+                  <a:ext uri="{FF2B5EF4-FFF2-40B4-BE49-F238E27FC236}">
+                    <a16:creationId xmlns:a16="http://schemas.microsoft.com/office/drawing/2014/main" id="{16F12825-39A4-E643-A09E-7D42014D4AFE}"/>
+                  </a:ext>
+                </a:extLst>
+              </p:cNvPr>
+              <p:cNvSpPr/>
+              <p:nvPr/>
+            </p:nvSpPr>
+            <p:spPr>
+              <a:xfrm>
+                <a:off x="5933243" y="3118068"/>
+                <a:ext cx="159227" cy="310932"/>
+              </a:xfrm>
+              <a:prstGeom prst="roundRect">
+                <a:avLst/>
+              </a:prstGeom>
+              <a:solidFill>
+                <a:srgbClr val="6FBB98"/>
+              </a:solidFill>
+              <a:ln>
+                <a:noFill/>
+              </a:ln>
+            </p:spPr>
+            <p:style>
+              <a:lnRef idx="2">
+                <a:schemeClr val="accent1">
+                  <a:shade val="50000"/>
+                </a:schemeClr>
+              </a:lnRef>
+              <a:fillRef idx="1">
+                <a:schemeClr val="accent1"/>
+              </a:fillRef>
+              <a:effectRef idx="0">
+                <a:schemeClr val="accent1"/>
+              </a:effectRef>
+              <a:fontRef idx="minor">
+                <a:schemeClr val="lt1"/>
+              </a:fontRef>
+            </p:style>
+            <p:txBody>
+              <a:bodyPr rtlCol="0" anchor="ctr"/>
+              <a:lstStyle/>
+              <a:p>
+                <a:pPr algn="ctr"/>
+                <a:endParaRPr lang="en-US"/>
+              </a:p>
+            </p:txBody>
+          </p:sp>
+        </p:grpSp>
+        <p:grpSp>
+          <p:nvGrpSpPr>
+            <p:cNvPr id="79" name="Group 78">
+              <a:extLst>
+                <a:ext uri="{FF2B5EF4-FFF2-40B4-BE49-F238E27FC236}">
+                  <a16:creationId xmlns:a16="http://schemas.microsoft.com/office/drawing/2014/main" id="{72A8E4F2-B13D-CD42-81B1-59742785EA71}"/>
+                </a:ext>
+              </a:extLst>
+            </p:cNvPr>
+            <p:cNvGrpSpPr/>
+            <p:nvPr/>
+          </p:nvGrpSpPr>
+          <p:grpSpPr>
+            <a:xfrm>
+              <a:off x="1237939" y="4244969"/>
+              <a:ext cx="304854" cy="299474"/>
+              <a:chOff x="5775952" y="3118068"/>
+              <a:chExt cx="316518" cy="310932"/>
+            </a:xfrm>
+          </p:grpSpPr>
+          <p:sp>
+            <p:nvSpPr>
+              <p:cNvPr id="80" name="Rounded Rectangle 79">
+                <a:extLst>
+                  <a:ext uri="{FF2B5EF4-FFF2-40B4-BE49-F238E27FC236}">
+                    <a16:creationId xmlns:a16="http://schemas.microsoft.com/office/drawing/2014/main" id="{8C41887B-B84D-0648-A86E-C81F7FBD58D6}"/>
+                  </a:ext>
+                </a:extLst>
+              </p:cNvPr>
+              <p:cNvSpPr/>
+              <p:nvPr/>
+            </p:nvSpPr>
+            <p:spPr>
+              <a:xfrm>
+                <a:off x="5775952" y="3118068"/>
+                <a:ext cx="159227" cy="310932"/>
+              </a:xfrm>
+              <a:prstGeom prst="roundRect">
+                <a:avLst/>
+              </a:prstGeom>
+              <a:solidFill>
+                <a:schemeClr val="bg1">
+                  <a:lumMod val="85000"/>
+                </a:schemeClr>
+              </a:solidFill>
+              <a:ln w="9525">
+                <a:noFill/>
+              </a:ln>
+            </p:spPr>
+            <p:style>
+              <a:lnRef idx="2">
+                <a:schemeClr val="accent1">
+                  <a:shade val="50000"/>
+                </a:schemeClr>
+              </a:lnRef>
+              <a:fillRef idx="1">
+                <a:schemeClr val="accent1"/>
+              </a:fillRef>
+              <a:effectRef idx="0">
+                <a:schemeClr val="accent1"/>
+              </a:effectRef>
+              <a:fontRef idx="minor">
+                <a:schemeClr val="lt1"/>
+              </a:fontRef>
+            </p:style>
+            <p:txBody>
+              <a:bodyPr rtlCol="0" anchor="ctr"/>
+              <a:lstStyle/>
+              <a:p>
+                <a:pPr algn="ctr"/>
+                <a:r>
+                  <a:rPr lang="en-US" dirty="0">
+                    <a:solidFill>
+                      <a:schemeClr val="tx1"/>
+                    </a:solidFill>
+                  </a:rPr>
+                  <a:t>i</a:t>
+                </a:r>
+              </a:p>
+            </p:txBody>
+          </p:sp>
+          <p:sp>
+            <p:nvSpPr>
+              <p:cNvPr id="81" name="Rounded Rectangle 80">
+                <a:extLst>
+                  <a:ext uri="{FF2B5EF4-FFF2-40B4-BE49-F238E27FC236}">
+                    <a16:creationId xmlns:a16="http://schemas.microsoft.com/office/drawing/2014/main" id="{84BA931A-0202-AC49-93B1-DA00ECF62D13}"/>
+                  </a:ext>
+                </a:extLst>
+              </p:cNvPr>
+              <p:cNvSpPr/>
+              <p:nvPr/>
+            </p:nvSpPr>
+            <p:spPr>
+              <a:xfrm>
+                <a:off x="5933243" y="3118068"/>
+                <a:ext cx="159227" cy="310932"/>
+              </a:xfrm>
+              <a:prstGeom prst="roundRect">
+                <a:avLst/>
+              </a:prstGeom>
+              <a:solidFill>
+                <a:schemeClr val="bg2">
+                  <a:lumMod val="75000"/>
+                </a:schemeClr>
+              </a:solidFill>
+              <a:ln w="9525">
+                <a:noFill/>
+              </a:ln>
+            </p:spPr>
+            <p:style>
+              <a:lnRef idx="2">
+                <a:schemeClr val="accent1">
+                  <a:shade val="50000"/>
+                </a:schemeClr>
+              </a:lnRef>
+              <a:fillRef idx="1">
+                <a:schemeClr val="accent1"/>
+              </a:fillRef>
+              <a:effectRef idx="0">
+                <a:schemeClr val="accent1"/>
+              </a:effectRef>
+              <a:fontRef idx="minor">
+                <a:schemeClr val="lt1"/>
+              </a:fontRef>
+            </p:style>
+            <p:txBody>
+              <a:bodyPr rtlCol="0" anchor="ctr"/>
+              <a:lstStyle/>
+              <a:p>
+                <a:pPr algn="ctr"/>
+                <a:r>
+                  <a:rPr lang="en-US" dirty="0">
+                    <a:solidFill>
+                      <a:schemeClr val="tx1"/>
+                    </a:solidFill>
+                  </a:rPr>
+                  <a:t>j</a:t>
+                </a:r>
+                <a:endParaRPr lang="en-US" dirty="0"/>
+              </a:p>
+            </p:txBody>
+          </p:sp>
+        </p:grpSp>
+        <p:grpSp>
+          <p:nvGrpSpPr>
+            <p:cNvPr id="27" name="Group 26">
+              <a:extLst>
+                <a:ext uri="{FF2B5EF4-FFF2-40B4-BE49-F238E27FC236}">
+                  <a16:creationId xmlns:a16="http://schemas.microsoft.com/office/drawing/2014/main" id="{B7B6EC3A-C2DF-4645-A0A9-13C0BBB90A43}"/>
+                </a:ext>
+              </a:extLst>
+            </p:cNvPr>
+            <p:cNvGrpSpPr/>
+            <p:nvPr/>
+          </p:nvGrpSpPr>
+          <p:grpSpPr>
+            <a:xfrm>
+              <a:off x="2456485" y="5126495"/>
+              <a:ext cx="304840" cy="299475"/>
+              <a:chOff x="5775966" y="3118068"/>
+              <a:chExt cx="316504" cy="310933"/>
+            </a:xfrm>
+          </p:grpSpPr>
+          <p:sp>
+            <p:nvSpPr>
+              <p:cNvPr id="28" name="Rounded Rectangle 27">
+                <a:extLst>
+                  <a:ext uri="{FF2B5EF4-FFF2-40B4-BE49-F238E27FC236}">
+                    <a16:creationId xmlns:a16="http://schemas.microsoft.com/office/drawing/2014/main" id="{0E45844A-EC3D-5D47-8666-37726444C331}"/>
+                  </a:ext>
+                </a:extLst>
+              </p:cNvPr>
+              <p:cNvSpPr/>
+              <p:nvPr/>
+            </p:nvSpPr>
+            <p:spPr>
+              <a:xfrm>
+                <a:off x="5775966" y="3118069"/>
+                <a:ext cx="159227" cy="310932"/>
+              </a:xfrm>
+              <a:prstGeom prst="roundRect">
+                <a:avLst/>
+              </a:prstGeom>
+              <a:solidFill>
+                <a:srgbClr val="4A69AF"/>
+              </a:solidFill>
+              <a:ln>
+                <a:noFill/>
+              </a:ln>
+            </p:spPr>
+            <p:style>
+              <a:lnRef idx="2">
+                <a:schemeClr val="accent1">
+                  <a:shade val="50000"/>
+                </a:schemeClr>
+              </a:lnRef>
+              <a:fillRef idx="1">
+                <a:schemeClr val="accent1"/>
+              </a:fillRef>
+              <a:effectRef idx="0">
+                <a:schemeClr val="accent1"/>
+              </a:effectRef>
+              <a:fontRef idx="minor">
+                <a:schemeClr val="lt1"/>
+              </a:fontRef>
+            </p:style>
+            <p:txBody>
+              <a:bodyPr rtlCol="0" anchor="ctr"/>
+              <a:lstStyle/>
+              <a:p>
+                <a:pPr algn="ctr"/>
+                <a:endParaRPr lang="en-US" dirty="0"/>
+              </a:p>
+            </p:txBody>
+          </p:sp>
+          <p:sp>
+            <p:nvSpPr>
+              <p:cNvPr id="29" name="Rounded Rectangle 28">
+                <a:extLst>
+                  <a:ext uri="{FF2B5EF4-FFF2-40B4-BE49-F238E27FC236}">
+                    <a16:creationId xmlns:a16="http://schemas.microsoft.com/office/drawing/2014/main" id="{9B395206-02E1-CE45-904B-2FAF0551730E}"/>
+                  </a:ext>
+                </a:extLst>
+              </p:cNvPr>
+              <p:cNvSpPr/>
+              <p:nvPr/>
+            </p:nvSpPr>
+            <p:spPr>
+              <a:xfrm>
+                <a:off x="5933243" y="3118068"/>
+                <a:ext cx="159227" cy="310932"/>
+              </a:xfrm>
+              <a:prstGeom prst="roundRect">
+                <a:avLst/>
+              </a:prstGeom>
+              <a:solidFill>
+                <a:srgbClr val="62C7D9"/>
+              </a:solidFill>
+              <a:ln>
+                <a:noFill/>
+              </a:ln>
+            </p:spPr>
+            <p:style>
+              <a:lnRef idx="2">
+                <a:schemeClr val="accent1">
+                  <a:shade val="50000"/>
+                </a:schemeClr>
+              </a:lnRef>
+              <a:fillRef idx="1">
+                <a:schemeClr val="accent1"/>
+              </a:fillRef>
+              <a:effectRef idx="0">
+                <a:schemeClr val="accent1"/>
+              </a:effectRef>
+              <a:fontRef idx="minor">
+                <a:schemeClr val="lt1"/>
+              </a:fontRef>
+            </p:style>
+            <p:txBody>
+              <a:bodyPr rtlCol="0" anchor="ctr"/>
+              <a:lstStyle/>
+              <a:p>
+                <a:pPr algn="ctr"/>
+                <a:endParaRPr lang="en-US"/>
+              </a:p>
+            </p:txBody>
+          </p:sp>
+        </p:grpSp>
+        <p:grpSp>
+          <p:nvGrpSpPr>
+            <p:cNvPr id="31" name="Group 30">
+              <a:extLst>
+                <a:ext uri="{FF2B5EF4-FFF2-40B4-BE49-F238E27FC236}">
+                  <a16:creationId xmlns:a16="http://schemas.microsoft.com/office/drawing/2014/main" id="{890B0DAD-45BE-DC4F-8BB6-D4535DF2E871}"/>
+                </a:ext>
+              </a:extLst>
+            </p:cNvPr>
+            <p:cNvGrpSpPr/>
+            <p:nvPr/>
+          </p:nvGrpSpPr>
+          <p:grpSpPr>
+            <a:xfrm>
+              <a:off x="2455539" y="5497688"/>
+              <a:ext cx="304854" cy="299474"/>
+              <a:chOff x="5775952" y="3118068"/>
+              <a:chExt cx="316518" cy="310932"/>
+            </a:xfrm>
+          </p:grpSpPr>
+          <p:sp>
+            <p:nvSpPr>
+              <p:cNvPr id="32" name="Rounded Rectangle 31">
+                <a:extLst>
+                  <a:ext uri="{FF2B5EF4-FFF2-40B4-BE49-F238E27FC236}">
+                    <a16:creationId xmlns:a16="http://schemas.microsoft.com/office/drawing/2014/main" id="{C3A0FCBC-35C1-3743-A1F8-AE4EC9994012}"/>
+                  </a:ext>
+                </a:extLst>
+              </p:cNvPr>
+              <p:cNvSpPr/>
+              <p:nvPr/>
+            </p:nvSpPr>
+            <p:spPr>
+              <a:xfrm>
+                <a:off x="5775952" y="3118068"/>
+                <a:ext cx="159227" cy="310932"/>
+              </a:xfrm>
+              <a:prstGeom prst="roundRect">
+                <a:avLst/>
+              </a:prstGeom>
+              <a:solidFill>
+                <a:srgbClr val="6FBB98"/>
+              </a:solidFill>
+              <a:ln>
+                <a:noFill/>
+              </a:ln>
+            </p:spPr>
+            <p:style>
+              <a:lnRef idx="2">
+                <a:schemeClr val="accent1">
+                  <a:shade val="50000"/>
+                </a:schemeClr>
+              </a:lnRef>
+              <a:fillRef idx="1">
+                <a:schemeClr val="accent1"/>
+              </a:fillRef>
+              <a:effectRef idx="0">
+                <a:schemeClr val="accent1"/>
+              </a:effectRef>
+              <a:fontRef idx="minor">
+                <a:schemeClr val="lt1"/>
+              </a:fontRef>
+            </p:style>
+            <p:txBody>
+              <a:bodyPr rtlCol="0" anchor="ctr"/>
+              <a:lstStyle/>
+              <a:p>
+                <a:pPr algn="ctr"/>
+                <a:endParaRPr lang="en-US" dirty="0"/>
+              </a:p>
+            </p:txBody>
+          </p:sp>
+          <p:sp>
+            <p:nvSpPr>
+              <p:cNvPr id="33" name="Rounded Rectangle 32">
+                <a:extLst>
+                  <a:ext uri="{FF2B5EF4-FFF2-40B4-BE49-F238E27FC236}">
+                    <a16:creationId xmlns:a16="http://schemas.microsoft.com/office/drawing/2014/main" id="{B2018B98-782C-8747-AC6B-F7168EB10928}"/>
+                  </a:ext>
+                </a:extLst>
+              </p:cNvPr>
+              <p:cNvSpPr/>
+              <p:nvPr/>
+            </p:nvSpPr>
+            <p:spPr>
+              <a:xfrm>
+                <a:off x="5933243" y="3118068"/>
+                <a:ext cx="159227" cy="310932"/>
+              </a:xfrm>
+              <a:prstGeom prst="roundRect">
+                <a:avLst/>
+              </a:prstGeom>
+              <a:solidFill>
+                <a:srgbClr val="860138"/>
+              </a:solidFill>
+              <a:ln>
+                <a:noFill/>
+              </a:ln>
+            </p:spPr>
+            <p:style>
+              <a:lnRef idx="2">
+                <a:schemeClr val="accent1">
+                  <a:shade val="50000"/>
+                </a:schemeClr>
+              </a:lnRef>
+              <a:fillRef idx="1">
+                <a:schemeClr val="accent1"/>
+              </a:fillRef>
+              <a:effectRef idx="0">
+                <a:schemeClr val="accent1"/>
+              </a:effectRef>
+              <a:fontRef idx="minor">
+                <a:schemeClr val="lt1"/>
+              </a:fontRef>
+            </p:style>
+            <p:txBody>
+              <a:bodyPr rtlCol="0" anchor="ctr"/>
+              <a:lstStyle/>
+              <a:p>
+                <a:pPr algn="ctr"/>
+                <a:endParaRPr lang="en-US"/>
+              </a:p>
+            </p:txBody>
+          </p:sp>
+        </p:grpSp>
+        <p:grpSp>
+          <p:nvGrpSpPr>
+            <p:cNvPr id="34" name="Group 33">
+              <a:extLst>
+                <a:ext uri="{FF2B5EF4-FFF2-40B4-BE49-F238E27FC236}">
+                  <a16:creationId xmlns:a16="http://schemas.microsoft.com/office/drawing/2014/main" id="{6CD0A1E2-54E5-2A45-9573-9A9F0494F9D4}"/>
+                </a:ext>
+              </a:extLst>
+            </p:cNvPr>
+            <p:cNvGrpSpPr/>
+            <p:nvPr/>
+          </p:nvGrpSpPr>
+          <p:grpSpPr>
+            <a:xfrm>
+              <a:off x="2455539" y="4762366"/>
+              <a:ext cx="304854" cy="299474"/>
+              <a:chOff x="5775952" y="3118068"/>
+              <a:chExt cx="316518" cy="310932"/>
+            </a:xfrm>
+          </p:grpSpPr>
+          <p:sp>
+            <p:nvSpPr>
+              <p:cNvPr id="35" name="Rounded Rectangle 34">
+                <a:extLst>
+                  <a:ext uri="{FF2B5EF4-FFF2-40B4-BE49-F238E27FC236}">
+                    <a16:creationId xmlns:a16="http://schemas.microsoft.com/office/drawing/2014/main" id="{DCE75C15-EE6F-9B49-8261-685BB5748A62}"/>
+                  </a:ext>
+                </a:extLst>
+              </p:cNvPr>
+              <p:cNvSpPr/>
+              <p:nvPr/>
+            </p:nvSpPr>
+            <p:spPr>
+              <a:xfrm>
+                <a:off x="5775952" y="3118068"/>
+                <a:ext cx="159227" cy="310932"/>
+              </a:xfrm>
+              <a:prstGeom prst="roundRect">
+                <a:avLst/>
+              </a:prstGeom>
+              <a:solidFill>
+                <a:srgbClr val="DED59B"/>
+              </a:solidFill>
+              <a:ln>
+                <a:noFill/>
+              </a:ln>
+            </p:spPr>
+            <p:style>
+              <a:lnRef idx="2">
+                <a:schemeClr val="accent1">
+                  <a:shade val="50000"/>
+                </a:schemeClr>
+              </a:lnRef>
+              <a:fillRef idx="1">
+                <a:schemeClr val="accent1"/>
+              </a:fillRef>
+              <a:effectRef idx="0">
+                <a:schemeClr val="accent1"/>
+              </a:effectRef>
+              <a:fontRef idx="minor">
+                <a:schemeClr val="lt1"/>
+              </a:fontRef>
+            </p:style>
+            <p:txBody>
+              <a:bodyPr rtlCol="0" anchor="ctr"/>
+              <a:lstStyle/>
+              <a:p>
+                <a:pPr algn="ctr"/>
+                <a:endParaRPr lang="en-US" dirty="0"/>
+              </a:p>
+            </p:txBody>
+          </p:sp>
+          <p:sp>
+            <p:nvSpPr>
+              <p:cNvPr id="36" name="Rounded Rectangle 35">
+                <a:extLst>
+                  <a:ext uri="{FF2B5EF4-FFF2-40B4-BE49-F238E27FC236}">
+                    <a16:creationId xmlns:a16="http://schemas.microsoft.com/office/drawing/2014/main" id="{A2D2FAFE-3C94-634D-A755-3C99C3175DC9}"/>
+                  </a:ext>
+                </a:extLst>
+              </p:cNvPr>
+              <p:cNvSpPr/>
+              <p:nvPr/>
+            </p:nvSpPr>
+            <p:spPr>
+              <a:xfrm>
+                <a:off x="5933243" y="3118068"/>
+                <a:ext cx="159227" cy="310932"/>
+              </a:xfrm>
+              <a:prstGeom prst="roundRect">
+                <a:avLst/>
+              </a:prstGeom>
+              <a:solidFill>
+                <a:srgbClr val="B77240"/>
+              </a:solidFill>
+              <a:ln>
+                <a:noFill/>
+              </a:ln>
+            </p:spPr>
+            <p:style>
+              <a:lnRef idx="2">
+                <a:schemeClr val="accent1">
+                  <a:shade val="50000"/>
+                </a:schemeClr>
+              </a:lnRef>
+              <a:fillRef idx="1">
+                <a:schemeClr val="accent1"/>
+              </a:fillRef>
+              <a:effectRef idx="0">
+                <a:schemeClr val="accent1"/>
+              </a:effectRef>
+              <a:fontRef idx="minor">
+                <a:schemeClr val="lt1"/>
+              </a:fontRef>
+            </p:style>
+            <p:txBody>
+              <a:bodyPr rtlCol="0" anchor="ctr"/>
+              <a:lstStyle/>
+              <a:p>
+                <a:pPr algn="ctr"/>
+                <a:endParaRPr lang="en-US"/>
+              </a:p>
+            </p:txBody>
+          </p:sp>
+        </p:grpSp>
+        <p:sp>
+          <p:nvSpPr>
+            <p:cNvPr id="37" name="TextBox 36">
+              <a:extLst>
+                <a:ext uri="{FF2B5EF4-FFF2-40B4-BE49-F238E27FC236}">
+                  <a16:creationId xmlns:a16="http://schemas.microsoft.com/office/drawing/2014/main" id="{14B6CFB5-6EE6-FF41-B10A-CEFD6AC81439}"/>
+                </a:ext>
+              </a:extLst>
+            </p:cNvPr>
+            <p:cNvSpPr txBox="1"/>
+            <p:nvPr/>
+          </p:nvSpPr>
+          <p:spPr>
+            <a:xfrm>
+              <a:off x="1134106" y="5749355"/>
+              <a:ext cx="565684" cy="307777"/>
+            </a:xfrm>
+            <a:prstGeom prst="rect">
+              <a:avLst/>
+            </a:prstGeom>
+            <a:noFill/>
+          </p:spPr>
+          <p:txBody>
+            <a:bodyPr wrap="square" rtlCol="0">
+              <a:spAutoFit/>
+            </a:bodyPr>
+            <a:lstStyle/>
+            <a:p>
+              <a:r>
+                <a:rPr lang="en-US" sz="1400" dirty="0">
+                  <a:latin typeface="Arial" panose="020B0604020202020204" pitchFamily="34" charset="0"/>
+                  <a:cs typeface="Arial" panose="020B0604020202020204" pitchFamily="34" charset="0"/>
+                </a:rPr>
+                <a:t>orig*</a:t>
+              </a:r>
+            </a:p>
+          </p:txBody>
+        </p:sp>
+        <p:sp>
+          <p:nvSpPr>
+            <p:cNvPr id="40" name="TextBox 39">
+              <a:extLst>
+                <a:ext uri="{FF2B5EF4-FFF2-40B4-BE49-F238E27FC236}">
+                  <a16:creationId xmlns:a16="http://schemas.microsoft.com/office/drawing/2014/main" id="{8AD635A3-A0E7-2349-BCE7-8CFE3D033242}"/>
+                </a:ext>
+              </a:extLst>
+            </p:cNvPr>
+            <p:cNvSpPr txBox="1"/>
+            <p:nvPr/>
+          </p:nvSpPr>
+          <p:spPr>
+            <a:xfrm>
+              <a:off x="2356226" y="5743808"/>
+              <a:ext cx="681575" cy="307777"/>
+            </a:xfrm>
+            <a:prstGeom prst="rect">
+              <a:avLst/>
+            </a:prstGeom>
+            <a:noFill/>
+          </p:spPr>
+          <p:txBody>
+            <a:bodyPr wrap="square" rtlCol="0">
+              <a:spAutoFit/>
+            </a:bodyPr>
+            <a:lstStyle/>
+            <a:p>
+              <a:r>
+                <a:rPr lang="en-US" sz="1400" dirty="0">
+                  <a:latin typeface="Arial" panose="020B0604020202020204" pitchFamily="34" charset="0"/>
+                  <a:cs typeface="Arial" panose="020B0604020202020204" pitchFamily="34" charset="0"/>
+                </a:rPr>
+                <a:t>new*</a:t>
+              </a:r>
+            </a:p>
+          </p:txBody>
+        </p:sp>
+        <p:cxnSp>
+          <p:nvCxnSpPr>
+            <p:cNvPr id="4" name="Straight Arrow Connector 3">
+              <a:extLst>
+                <a:ext uri="{FF2B5EF4-FFF2-40B4-BE49-F238E27FC236}">
+                  <a16:creationId xmlns:a16="http://schemas.microsoft.com/office/drawing/2014/main" id="{858FF591-AFEC-6B4C-BD17-1BB3A23CA37C}"/>
+                </a:ext>
+              </a:extLst>
+            </p:cNvPr>
+            <p:cNvCxnSpPr>
+              <a:cxnSpLocks/>
+            </p:cNvCxnSpPr>
+            <p:nvPr/>
+          </p:nvCxnSpPr>
+          <p:spPr>
+            <a:xfrm>
+              <a:off x="1607560" y="5276232"/>
+              <a:ext cx="778696" cy="0"/>
+            </a:xfrm>
+            <a:prstGeom prst="straightConnector1">
+              <a:avLst/>
+            </a:prstGeom>
+            <a:ln w="28575">
+              <a:tailEnd type="triangle"/>
+            </a:ln>
+          </p:spPr>
+          <p:style>
+            <a:lnRef idx="1">
+              <a:schemeClr val="dk1"/>
+            </a:lnRef>
+            <a:fillRef idx="0">
+              <a:schemeClr val="dk1"/>
+            </a:fillRef>
+            <a:effectRef idx="0">
+              <a:schemeClr val="dk1"/>
+            </a:effectRef>
+            <a:fontRef idx="minor">
+              <a:schemeClr val="tx1"/>
+            </a:fontRef>
+          </p:style>
+        </p:cxnSp>
+        <p:sp>
+          <p:nvSpPr>
+            <p:cNvPr id="46" name="TextBox 45">
+              <a:extLst>
+                <a:ext uri="{FF2B5EF4-FFF2-40B4-BE49-F238E27FC236}">
+                  <a16:creationId xmlns:a16="http://schemas.microsoft.com/office/drawing/2014/main" id="{A8BA2B48-A7B3-8C4D-A9F4-050C9C4EAB9A}"/>
+                </a:ext>
+              </a:extLst>
+            </p:cNvPr>
+            <p:cNvSpPr txBox="1"/>
+            <p:nvPr/>
+          </p:nvSpPr>
+          <p:spPr>
+            <a:xfrm>
+              <a:off x="1614886" y="4988426"/>
+              <a:ext cx="773669" cy="307777"/>
+            </a:xfrm>
+            <a:prstGeom prst="rect">
+              <a:avLst/>
+            </a:prstGeom>
+            <a:noFill/>
+          </p:spPr>
+          <p:txBody>
+            <a:bodyPr wrap="square" rtlCol="0">
+              <a:spAutoFit/>
+            </a:bodyPr>
+            <a:lstStyle/>
+            <a:p>
+              <a:pPr algn="ctr"/>
+              <a:r>
+                <a:rPr lang="en-US" sz="1400" dirty="0">
+                  <a:latin typeface="Arial" panose="020B0604020202020204" pitchFamily="34" charset="0"/>
+                  <a:cs typeface="Arial" panose="020B0604020202020204" pitchFamily="34" charset="0"/>
+                </a:rPr>
+                <a:t>shuffle</a:t>
+              </a:r>
+            </a:p>
+          </p:txBody>
+        </p:sp>
+        <p:grpSp>
+          <p:nvGrpSpPr>
+            <p:cNvPr id="47" name="Group 46">
+              <a:extLst>
+                <a:ext uri="{FF2B5EF4-FFF2-40B4-BE49-F238E27FC236}">
+                  <a16:creationId xmlns:a16="http://schemas.microsoft.com/office/drawing/2014/main" id="{774444CA-4B29-8946-AEF6-0C191BEF5B97}"/>
+                </a:ext>
+              </a:extLst>
+            </p:cNvPr>
+            <p:cNvGrpSpPr/>
+            <p:nvPr/>
+          </p:nvGrpSpPr>
+          <p:grpSpPr>
+            <a:xfrm>
+              <a:off x="2452457" y="4239056"/>
+              <a:ext cx="304854" cy="299474"/>
+              <a:chOff x="5775952" y="3118068"/>
+              <a:chExt cx="316518" cy="310932"/>
+            </a:xfrm>
+          </p:grpSpPr>
+          <p:sp>
+            <p:nvSpPr>
+              <p:cNvPr id="54" name="Rounded Rectangle 53">
+                <a:extLst>
+                  <a:ext uri="{FF2B5EF4-FFF2-40B4-BE49-F238E27FC236}">
+                    <a16:creationId xmlns:a16="http://schemas.microsoft.com/office/drawing/2014/main" id="{C1D5B1C9-D531-B14C-9F5D-112AA5BEB16D}"/>
+                  </a:ext>
+                </a:extLst>
+              </p:cNvPr>
+              <p:cNvSpPr/>
+              <p:nvPr/>
+            </p:nvSpPr>
+            <p:spPr>
+              <a:xfrm>
+                <a:off x="5775952" y="3118068"/>
+                <a:ext cx="159227" cy="310932"/>
+              </a:xfrm>
+              <a:prstGeom prst="roundRect">
+                <a:avLst/>
+              </a:prstGeom>
+              <a:solidFill>
+                <a:schemeClr val="bg1">
+                  <a:lumMod val="85000"/>
+                </a:schemeClr>
+              </a:solidFill>
+              <a:ln w="9525">
+                <a:noFill/>
+              </a:ln>
+            </p:spPr>
+            <p:style>
+              <a:lnRef idx="2">
+                <a:schemeClr val="accent1">
+                  <a:shade val="50000"/>
+                </a:schemeClr>
+              </a:lnRef>
+              <a:fillRef idx="1">
+                <a:schemeClr val="accent1"/>
+              </a:fillRef>
+              <a:effectRef idx="0">
+                <a:schemeClr val="accent1"/>
+              </a:effectRef>
+              <a:fontRef idx="minor">
+                <a:schemeClr val="lt1"/>
+              </a:fontRef>
+            </p:style>
+            <p:txBody>
+              <a:bodyPr rtlCol="0" anchor="ctr"/>
+              <a:lstStyle/>
+              <a:p>
+                <a:pPr algn="ctr"/>
+                <a:r>
+                  <a:rPr lang="en-US" dirty="0">
+                    <a:solidFill>
+                      <a:schemeClr val="tx1"/>
+                    </a:solidFill>
+                  </a:rPr>
+                  <a:t>i</a:t>
+                </a:r>
+              </a:p>
+            </p:txBody>
+          </p:sp>
+          <p:sp>
+            <p:nvSpPr>
+              <p:cNvPr id="55" name="Rounded Rectangle 54">
+                <a:extLst>
+                  <a:ext uri="{FF2B5EF4-FFF2-40B4-BE49-F238E27FC236}">
+                    <a16:creationId xmlns:a16="http://schemas.microsoft.com/office/drawing/2014/main" id="{9DB9E02F-6BF4-B04D-A29D-CB6AE63FD4A9}"/>
+                  </a:ext>
+                </a:extLst>
+              </p:cNvPr>
+              <p:cNvSpPr/>
+              <p:nvPr/>
+            </p:nvSpPr>
+            <p:spPr>
+              <a:xfrm>
+                <a:off x="5933243" y="3118068"/>
+                <a:ext cx="159227" cy="310932"/>
+              </a:xfrm>
+              <a:prstGeom prst="roundRect">
+                <a:avLst/>
+              </a:prstGeom>
+              <a:solidFill>
+                <a:schemeClr val="bg2">
+                  <a:lumMod val="75000"/>
+                </a:schemeClr>
+              </a:solidFill>
+              <a:ln w="9525">
+                <a:noFill/>
+              </a:ln>
+            </p:spPr>
+            <p:style>
+              <a:lnRef idx="2">
+                <a:schemeClr val="accent1">
+                  <a:shade val="50000"/>
+                </a:schemeClr>
+              </a:lnRef>
+              <a:fillRef idx="1">
+                <a:schemeClr val="accent1"/>
+              </a:fillRef>
+              <a:effectRef idx="0">
+                <a:schemeClr val="accent1"/>
+              </a:effectRef>
+              <a:fontRef idx="minor">
+                <a:schemeClr val="lt1"/>
+              </a:fontRef>
+            </p:style>
+            <p:txBody>
+              <a:bodyPr rtlCol="0" anchor="ctr"/>
+              <a:lstStyle/>
+              <a:p>
+                <a:pPr algn="ctr"/>
+                <a:r>
+                  <a:rPr lang="en-US" dirty="0">
+                    <a:solidFill>
+                      <a:schemeClr val="tx1"/>
+                    </a:solidFill>
+                  </a:rPr>
+                  <a:t>j</a:t>
+                </a:r>
+                <a:endParaRPr lang="en-US" dirty="0"/>
+              </a:p>
+            </p:txBody>
+          </p:sp>
+        </p:grpSp>
+        <p:sp>
+          <p:nvSpPr>
+            <p:cNvPr id="56" name="TextBox 55">
+              <a:extLst>
+                <a:ext uri="{FF2B5EF4-FFF2-40B4-BE49-F238E27FC236}">
+                  <a16:creationId xmlns:a16="http://schemas.microsoft.com/office/drawing/2014/main" id="{B6706112-BC15-9C43-99CD-1516E57B7003}"/>
+                </a:ext>
+              </a:extLst>
+            </p:cNvPr>
+            <p:cNvSpPr txBox="1"/>
+            <p:nvPr/>
+          </p:nvSpPr>
+          <p:spPr>
+            <a:xfrm>
+              <a:off x="2713644" y="5122343"/>
+              <a:ext cx="351267" cy="307777"/>
+            </a:xfrm>
+            <a:prstGeom prst="rect">
+              <a:avLst/>
+            </a:prstGeom>
+            <a:noFill/>
+          </p:spPr>
+          <p:txBody>
+            <a:bodyPr wrap="square" rtlCol="0">
+              <a:spAutoFit/>
+            </a:bodyPr>
+            <a:lstStyle/>
+            <a:p>
+              <a:r>
+                <a:rPr lang="en-US" sz="1400" b="1" dirty="0">
+                  <a:solidFill>
+                    <a:srgbClr val="FF0000"/>
+                  </a:solidFill>
+                  <a:latin typeface="Arial" panose="020B0604020202020204" pitchFamily="34" charset="0"/>
+                  <a:cs typeface="Arial" panose="020B0604020202020204" pitchFamily="34" charset="0"/>
+                </a:rPr>
+                <a:t>╳</a:t>
+              </a:r>
+            </a:p>
+          </p:txBody>
+        </p:sp>
+        <p:sp>
+          <p:nvSpPr>
+            <p:cNvPr id="58" name="TextBox 57">
+              <a:extLst>
+                <a:ext uri="{FF2B5EF4-FFF2-40B4-BE49-F238E27FC236}">
+                  <a16:creationId xmlns:a16="http://schemas.microsoft.com/office/drawing/2014/main" id="{0714BD0B-CB58-3140-B8AD-C7FD3D7D7612}"/>
+                </a:ext>
+              </a:extLst>
+            </p:cNvPr>
+            <p:cNvSpPr txBox="1"/>
+            <p:nvPr/>
+          </p:nvSpPr>
+          <p:spPr>
+            <a:xfrm>
+              <a:off x="2713644" y="5493536"/>
+              <a:ext cx="351267" cy="307777"/>
+            </a:xfrm>
+            <a:prstGeom prst="rect">
+              <a:avLst/>
+            </a:prstGeom>
+            <a:noFill/>
+          </p:spPr>
+          <p:txBody>
+            <a:bodyPr wrap="square" rtlCol="0">
+              <a:spAutoFit/>
+            </a:bodyPr>
+            <a:lstStyle/>
+            <a:p>
+              <a:r>
+                <a:rPr lang="en-US" sz="1400" b="1" dirty="0">
+                  <a:solidFill>
+                    <a:srgbClr val="FF0000"/>
+                  </a:solidFill>
+                  <a:latin typeface="Arial" panose="020B0604020202020204" pitchFamily="34" charset="0"/>
+                  <a:cs typeface="Arial" panose="020B0604020202020204" pitchFamily="34" charset="0"/>
+                </a:rPr>
+                <a:t>╳</a:t>
+              </a:r>
+            </a:p>
+          </p:txBody>
+        </p:sp>
+        <p:sp>
+          <p:nvSpPr>
+            <p:cNvPr id="59" name="TextBox 58">
+              <a:extLst>
+                <a:ext uri="{FF2B5EF4-FFF2-40B4-BE49-F238E27FC236}">
+                  <a16:creationId xmlns:a16="http://schemas.microsoft.com/office/drawing/2014/main" id="{FD88F0DF-2F1C-344A-907C-741938B89EE1}"/>
+                </a:ext>
+              </a:extLst>
+            </p:cNvPr>
+            <p:cNvSpPr txBox="1"/>
+            <p:nvPr/>
+          </p:nvSpPr>
+          <p:spPr>
+            <a:xfrm>
+              <a:off x="2712698" y="4734452"/>
+              <a:ext cx="351267" cy="400110"/>
+            </a:xfrm>
+            <a:prstGeom prst="rect">
+              <a:avLst/>
+            </a:prstGeom>
+            <a:noFill/>
+          </p:spPr>
+          <p:txBody>
+            <a:bodyPr wrap="square" rtlCol="0">
+              <a:spAutoFit/>
+            </a:bodyPr>
+            <a:lstStyle/>
+            <a:p>
+              <a:r>
+                <a:rPr lang="en-US" sz="2000" b="1" dirty="0">
+                  <a:solidFill>
+                    <a:srgbClr val="00B050"/>
+                  </a:solidFill>
+                  <a:latin typeface="Arial" panose="020B0604020202020204" pitchFamily="34" charset="0"/>
+                  <a:cs typeface="Arial" panose="020B0604020202020204" pitchFamily="34" charset="0"/>
+                </a:rPr>
+                <a:t>✓</a:t>
+              </a:r>
+            </a:p>
+          </p:txBody>
+        </p:sp>
+        <p:sp>
+          <p:nvSpPr>
+            <p:cNvPr id="60" name="TextBox 59">
+              <a:extLst>
+                <a:ext uri="{FF2B5EF4-FFF2-40B4-BE49-F238E27FC236}">
+                  <a16:creationId xmlns:a16="http://schemas.microsoft.com/office/drawing/2014/main" id="{8976CAFE-0458-2E43-A064-886DF39B5365}"/>
+                </a:ext>
+              </a:extLst>
+            </p:cNvPr>
+            <p:cNvSpPr txBox="1"/>
+            <p:nvPr/>
+          </p:nvSpPr>
+          <p:spPr>
+            <a:xfrm>
+              <a:off x="3075682" y="4758214"/>
+              <a:ext cx="629178" cy="307777"/>
+            </a:xfrm>
+            <a:prstGeom prst="rect">
+              <a:avLst/>
+            </a:prstGeom>
+            <a:noFill/>
+          </p:spPr>
+          <p:txBody>
+            <a:bodyPr wrap="square" rtlCol="0">
+              <a:spAutoFit/>
+            </a:bodyPr>
+            <a:lstStyle/>
+            <a:p>
+              <a:r>
+                <a:rPr lang="en-US" sz="1400" b="1" dirty="0">
+                  <a:solidFill>
+                    <a:srgbClr val="00B050"/>
+                  </a:solidFill>
+                  <a:latin typeface="Arial" panose="020B0604020202020204" pitchFamily="34" charset="0"/>
+                  <a:cs typeface="Arial" panose="020B0604020202020204" pitchFamily="34" charset="0"/>
+                </a:rPr>
+                <a:t>valid</a:t>
+              </a:r>
+            </a:p>
+          </p:txBody>
+        </p:sp>
+        <p:sp>
+          <p:nvSpPr>
+            <p:cNvPr id="61" name="TextBox 60">
+              <a:extLst>
+                <a:ext uri="{FF2B5EF4-FFF2-40B4-BE49-F238E27FC236}">
+                  <a16:creationId xmlns:a16="http://schemas.microsoft.com/office/drawing/2014/main" id="{27FC664F-7CFD-084B-BF21-DAF5F132CA58}"/>
+                </a:ext>
+              </a:extLst>
+            </p:cNvPr>
+            <p:cNvSpPr txBox="1"/>
+            <p:nvPr/>
+          </p:nvSpPr>
+          <p:spPr>
+            <a:xfrm>
+              <a:off x="3075681" y="5046856"/>
+              <a:ext cx="1945470" cy="492443"/>
+            </a:xfrm>
+            <a:prstGeom prst="rect">
+              <a:avLst/>
+            </a:prstGeom>
+            <a:noFill/>
+          </p:spPr>
+          <p:txBody>
+            <a:bodyPr wrap="square" rtlCol="0">
+              <a:spAutoFit/>
+            </a:bodyPr>
+            <a:lstStyle/>
+            <a:p>
+              <a:pPr algn="just"/>
+              <a:r>
+                <a:rPr lang="en-US" sz="1300" dirty="0">
+                  <a:solidFill>
+                    <a:srgbClr val="FF0000"/>
+                  </a:solidFill>
+                  <a:latin typeface="Arial" panose="020B0604020202020204" pitchFamily="34" charset="0"/>
+                  <a:cs typeface="Arial" panose="020B0604020202020204" pitchFamily="34" charset="0"/>
+                </a:rPr>
+                <a:t>distance between </a:t>
+              </a:r>
+              <a:r>
+                <a:rPr lang="en-US" sz="1300" b="1" i="1" dirty="0">
+                  <a:solidFill>
+                    <a:srgbClr val="FF0000"/>
+                  </a:solidFill>
+                  <a:latin typeface="Arial" panose="020B0604020202020204" pitchFamily="34" charset="0"/>
+                  <a:cs typeface="Arial" panose="020B0604020202020204" pitchFamily="34" charset="0"/>
+                </a:rPr>
+                <a:t>i</a:t>
+              </a:r>
+              <a:r>
+                <a:rPr lang="en-US" sz="1300" dirty="0">
+                  <a:solidFill>
+                    <a:srgbClr val="FF0000"/>
+                  </a:solidFill>
+                  <a:latin typeface="Arial" panose="020B0604020202020204" pitchFamily="34" charset="0"/>
+                  <a:cs typeface="Arial" panose="020B0604020202020204" pitchFamily="34" charset="0"/>
+                </a:rPr>
+                <a:t> and </a:t>
+              </a:r>
+              <a:r>
+                <a:rPr lang="en-US" sz="1300" b="1" i="1" dirty="0">
+                  <a:solidFill>
+                    <a:srgbClr val="FF0000"/>
+                  </a:solidFill>
+                  <a:latin typeface="Arial" panose="020B0604020202020204" pitchFamily="34" charset="0"/>
+                  <a:cs typeface="Arial" panose="020B0604020202020204" pitchFamily="34" charset="0"/>
+                </a:rPr>
+                <a:t>j</a:t>
+              </a:r>
+              <a:r>
+                <a:rPr lang="en-US" sz="1300" dirty="0">
+                  <a:solidFill>
+                    <a:srgbClr val="FF0000"/>
+                  </a:solidFill>
+                  <a:latin typeface="Arial" panose="020B0604020202020204" pitchFamily="34" charset="0"/>
+                  <a:cs typeface="Arial" panose="020B0604020202020204" pitchFamily="34" charset="0"/>
+                </a:rPr>
+                <a:t> not greater than 2Mb</a:t>
+              </a:r>
+            </a:p>
+          </p:txBody>
+        </p:sp>
+        <p:sp>
+          <p:nvSpPr>
+            <p:cNvPr id="62" name="TextBox 61">
+              <a:extLst>
+                <a:ext uri="{FF2B5EF4-FFF2-40B4-BE49-F238E27FC236}">
+                  <a16:creationId xmlns:a16="http://schemas.microsoft.com/office/drawing/2014/main" id="{CF53A2F4-B774-9A4C-A26B-FA7E866BC103}"/>
+                </a:ext>
+              </a:extLst>
+            </p:cNvPr>
+            <p:cNvSpPr txBox="1"/>
+            <p:nvPr/>
+          </p:nvSpPr>
+          <p:spPr>
+            <a:xfrm>
+              <a:off x="3076869" y="5499498"/>
+              <a:ext cx="2166166" cy="307777"/>
+            </a:xfrm>
+            <a:prstGeom prst="rect">
+              <a:avLst/>
+            </a:prstGeom>
+            <a:noFill/>
+          </p:spPr>
+          <p:txBody>
+            <a:bodyPr wrap="square" rtlCol="0">
+              <a:spAutoFit/>
+            </a:bodyPr>
+            <a:lstStyle/>
+            <a:p>
+              <a:pPr algn="just"/>
+              <a:r>
+                <a:rPr lang="en-US" sz="1400" b="1" i="1" dirty="0">
+                  <a:solidFill>
+                    <a:srgbClr val="FF0000"/>
+                  </a:solidFill>
+                  <a:latin typeface="Arial" panose="020B0604020202020204" pitchFamily="34" charset="0"/>
+                  <a:cs typeface="Arial" panose="020B0604020202020204" pitchFamily="34" charset="0"/>
+                </a:rPr>
+                <a:t>i</a:t>
+              </a:r>
+              <a:r>
+                <a:rPr lang="en-US" sz="1400" dirty="0">
+                  <a:solidFill>
+                    <a:srgbClr val="FF0000"/>
+                  </a:solidFill>
+                  <a:latin typeface="Arial" panose="020B0604020202020204" pitchFamily="34" charset="0"/>
+                  <a:cs typeface="Arial" panose="020B0604020202020204" pitchFamily="34" charset="0"/>
+                </a:rPr>
+                <a:t> &gt; </a:t>
+              </a:r>
+              <a:r>
+                <a:rPr lang="en-US" sz="1400" b="1" i="1" dirty="0">
+                  <a:solidFill>
+                    <a:srgbClr val="FF0000"/>
+                  </a:solidFill>
+                  <a:latin typeface="Arial" panose="020B0604020202020204" pitchFamily="34" charset="0"/>
+                  <a:cs typeface="Arial" panose="020B0604020202020204" pitchFamily="34" charset="0"/>
+                </a:rPr>
+                <a:t>j</a:t>
+              </a:r>
+              <a:r>
+                <a:rPr lang="en-US" sz="1400" dirty="0">
+                  <a:solidFill>
+                    <a:srgbClr val="FF0000"/>
+                  </a:solidFill>
+                  <a:latin typeface="Arial" panose="020B0604020202020204" pitchFamily="34" charset="0"/>
+                  <a:cs typeface="Arial" panose="020B0604020202020204" pitchFamily="34" charset="0"/>
+                </a:rPr>
+                <a:t> &amp; present in orig set</a:t>
+              </a:r>
+            </a:p>
+          </p:txBody>
+        </p:sp>
+      </p:grpSp>
+      <p:cxnSp>
+        <p:nvCxnSpPr>
+          <p:cNvPr id="9" name="Straight Connector 8">
+            <a:extLst>
+              <a:ext uri="{FF2B5EF4-FFF2-40B4-BE49-F238E27FC236}">
+                <a16:creationId xmlns:a16="http://schemas.microsoft.com/office/drawing/2014/main" id="{FF40C9C0-F4F5-6846-B965-91C2E0962405}"/>
+              </a:ext>
+            </a:extLst>
+          </p:cNvPr>
+          <p:cNvCxnSpPr>
+            <a:cxnSpLocks/>
+          </p:cNvCxnSpPr>
+          <p:nvPr/>
+        </p:nvCxnSpPr>
+        <p:spPr>
+          <a:xfrm flipV="1">
+            <a:off x="1347502" y="483501"/>
+            <a:ext cx="1374478" cy="499042"/>
+          </a:xfrm>
+          <a:prstGeom prst="line">
+            <a:avLst/>
+          </a:prstGeom>
+          <a:ln w="12700">
+            <a:solidFill>
+              <a:schemeClr val="tx1"/>
+            </a:solidFill>
+          </a:ln>
+        </p:spPr>
+        <p:style>
+          <a:lnRef idx="1">
+            <a:schemeClr val="dk1"/>
+          </a:lnRef>
+          <a:fillRef idx="0">
+            <a:schemeClr val="dk1"/>
+          </a:fillRef>
+          <a:effectRef idx="0">
+            <a:schemeClr val="dk1"/>
+          </a:effectRef>
+          <a:fontRef idx="minor">
+            <a:schemeClr val="tx1"/>
+          </a:fontRef>
+        </p:style>
+      </p:cxnSp>
+      <p:sp>
+        <p:nvSpPr>
+          <p:cNvPr id="10" name="Rectangle 9">
+            <a:extLst>
+              <a:ext uri="{FF2B5EF4-FFF2-40B4-BE49-F238E27FC236}">
+                <a16:creationId xmlns:a16="http://schemas.microsoft.com/office/drawing/2014/main" id="{81F22AF1-2EAD-9F4C-BE9F-8D840527F503}"/>
+              </a:ext>
+            </a:extLst>
+          </p:cNvPr>
+          <p:cNvSpPr/>
+          <p:nvPr/>
+        </p:nvSpPr>
+        <p:spPr>
+          <a:xfrm>
+            <a:off x="2721987" y="483502"/>
+            <a:ext cx="2902673" cy="2100072"/>
+          </a:xfrm>
+          <a:prstGeom prst="rect">
+            <a:avLst/>
+          </a:prstGeom>
+          <a:noFill/>
+          <a:ln>
+            <a:solidFill>
+              <a:schemeClr val="tx1"/>
+            </a:solidFill>
+          </a:ln>
+        </p:spPr>
+        <p:style>
+          <a:lnRef idx="2">
+            <a:schemeClr val="accent1">
+              <a:shade val="50000"/>
+            </a:schemeClr>
+          </a:lnRef>
+          <a:fillRef idx="1">
+            <a:schemeClr val="accent1"/>
+          </a:fillRef>
+          <a:effectRef idx="0">
+            <a:schemeClr val="accent1"/>
+          </a:effectRef>
+          <a:fontRef idx="minor">
+            <a:schemeClr val="lt1"/>
+          </a:fontRef>
+        </p:style>
+        <p:txBody>
+          <a:bodyPr rot="0" spcFirstLastPara="0" vertOverflow="overflow" horzOverflow="overflow" vert="horz" wrap="square" lIns="91440" tIns="45720" rIns="91440" bIns="45720" numCol="1" spcCol="0" rtlCol="0" fromWordArt="0" anchor="ctr" anchorCtr="0" forceAA="0" compatLnSpc="1">
+            <a:prstTxWarp prst="textNoShape">
+              <a:avLst/>
+            </a:prstTxWarp>
+            <a:noAutofit/>
+          </a:bodyPr>
+          <a:lstStyle/>
+          <a:p>
+            <a:pPr algn="ctr"/>
+            <a:endParaRPr lang="en-US"/>
+          </a:p>
+        </p:txBody>
+      </p:sp>
+      <p:cxnSp>
+        <p:nvCxnSpPr>
+          <p:cNvPr id="65" name="Straight Connector 64">
+            <a:extLst>
+              <a:ext uri="{FF2B5EF4-FFF2-40B4-BE49-F238E27FC236}">
+                <a16:creationId xmlns:a16="http://schemas.microsoft.com/office/drawing/2014/main" id="{7A67F496-C5E0-C243-A114-99735D499282}"/>
+              </a:ext>
+            </a:extLst>
+          </p:cNvPr>
+          <p:cNvCxnSpPr>
+            <a:cxnSpLocks/>
+          </p:cNvCxnSpPr>
+          <p:nvPr/>
+        </p:nvCxnSpPr>
+        <p:spPr>
+          <a:xfrm>
+            <a:off x="1331069" y="1050117"/>
+            <a:ext cx="1390917" cy="1533463"/>
+          </a:xfrm>
+          <a:prstGeom prst="line">
+            <a:avLst/>
+          </a:prstGeom>
+          <a:ln w="12700"/>
+        </p:spPr>
+        <p:style>
+          <a:lnRef idx="1">
+            <a:schemeClr val="dk1"/>
+          </a:lnRef>
+          <a:fillRef idx="0">
+            <a:schemeClr val="dk1"/>
+          </a:fillRef>
+          <a:effectRef idx="0">
+            <a:schemeClr val="dk1"/>
+          </a:effectRef>
+          <a:fontRef idx="minor">
+            <a:schemeClr val="tx1"/>
+          </a:fontRef>
+        </p:style>
+      </p:cxnSp>
+      <p:sp>
+        <p:nvSpPr>
+          <p:cNvPr id="78" name="Rectangle 77">
+            <a:extLst>
+              <a:ext uri="{FF2B5EF4-FFF2-40B4-BE49-F238E27FC236}">
+                <a16:creationId xmlns:a16="http://schemas.microsoft.com/office/drawing/2014/main" id="{DFEC6C9C-2230-2648-A7DA-B402E592029D}"/>
+              </a:ext>
+            </a:extLst>
+          </p:cNvPr>
+          <p:cNvSpPr/>
+          <p:nvPr/>
+        </p:nvSpPr>
+        <p:spPr>
+          <a:xfrm>
+            <a:off x="1235105" y="982543"/>
+            <a:ext cx="109416" cy="79162"/>
+          </a:xfrm>
+          <a:prstGeom prst="rect">
+            <a:avLst/>
+          </a:prstGeom>
+          <a:noFill/>
+          <a:ln>
+            <a:solidFill>
+              <a:schemeClr val="tx1"/>
+            </a:solidFill>
+          </a:ln>
+        </p:spPr>
+        <p:style>
+          <a:lnRef idx="2">
+            <a:schemeClr val="accent1">
+              <a:shade val="50000"/>
+            </a:schemeClr>
+          </a:lnRef>
+          <a:fillRef idx="1">
+            <a:schemeClr val="accent1"/>
+          </a:fillRef>
+          <a:effectRef idx="0">
+            <a:schemeClr val="accent1"/>
+          </a:effectRef>
+          <a:fontRef idx="minor">
+            <a:schemeClr val="lt1"/>
+          </a:fontRef>
+        </p:style>
+        <p:txBody>
+          <a:bodyPr rot="0" spcFirstLastPara="0" vertOverflow="overflow" horzOverflow="overflow" vert="horz" wrap="square" lIns="91440" tIns="45720" rIns="91440" bIns="45720" numCol="1" spcCol="0" rtlCol="0" fromWordArt="0" anchor="ctr" anchorCtr="0" forceAA="0" compatLnSpc="1">
+            <a:prstTxWarp prst="textNoShape">
+              <a:avLst/>
+            </a:prstTxWarp>
+            <a:noAutofit/>
+          </a:bodyPr>
+          <a:lstStyle/>
+          <a:p>
+            <a:pPr algn="ctr"/>
+            <a:endParaRPr lang="en-US"/>
+          </a:p>
+        </p:txBody>
+      </p:sp>
+      <p:grpSp>
+        <p:nvGrpSpPr>
+          <p:cNvPr id="18" name="Group 17">
+            <a:extLst>
+              <a:ext uri="{FF2B5EF4-FFF2-40B4-BE49-F238E27FC236}">
+                <a16:creationId xmlns:a16="http://schemas.microsoft.com/office/drawing/2014/main" id="{F78FE8E0-0140-7C4C-8F0C-3EAB74563682}"/>
+              </a:ext>
+            </a:extLst>
+          </p:cNvPr>
+          <p:cNvGrpSpPr/>
+          <p:nvPr/>
+        </p:nvGrpSpPr>
+        <p:grpSpPr>
+          <a:xfrm>
+            <a:off x="6182318" y="2432921"/>
+            <a:ext cx="2912734" cy="400110"/>
+            <a:chOff x="979762" y="5621563"/>
+            <a:chExt cx="2912734" cy="400110"/>
+          </a:xfrm>
+        </p:grpSpPr>
+        <p:sp>
+          <p:nvSpPr>
+            <p:cNvPr id="64" name="TextBox 63">
+              <a:extLst>
+                <a:ext uri="{FF2B5EF4-FFF2-40B4-BE49-F238E27FC236}">
+                  <a16:creationId xmlns:a16="http://schemas.microsoft.com/office/drawing/2014/main" id="{7D4AC1EF-C6EB-1E4A-92A6-06488DB68B37}"/>
+                </a:ext>
+              </a:extLst>
+            </p:cNvPr>
+            <p:cNvSpPr txBox="1"/>
+            <p:nvPr/>
+          </p:nvSpPr>
+          <p:spPr>
+            <a:xfrm>
+              <a:off x="979762" y="5621563"/>
+              <a:ext cx="369524" cy="400110"/>
+            </a:xfrm>
+            <a:prstGeom prst="rect">
+              <a:avLst/>
+            </a:prstGeom>
+            <a:noFill/>
+          </p:spPr>
+          <p:txBody>
+            <a:bodyPr wrap="square" rtlCol="0">
+              <a:spAutoFit/>
+            </a:bodyPr>
+            <a:lstStyle/>
+            <a:p>
+              <a:r>
+                <a:rPr lang="en-US" sz="2000" dirty="0">
+                  <a:latin typeface="Arial" panose="020B0604020202020204" pitchFamily="34" charset="0"/>
+                  <a:cs typeface="Arial" panose="020B0604020202020204" pitchFamily="34" charset="0"/>
+                </a:rPr>
+                <a:t>*</a:t>
+              </a:r>
+            </a:p>
+          </p:txBody>
+        </p:sp>
+        <p:sp>
+          <p:nvSpPr>
+            <p:cNvPr id="82" name="TextBox 81">
+              <a:extLst>
+                <a:ext uri="{FF2B5EF4-FFF2-40B4-BE49-F238E27FC236}">
+                  <a16:creationId xmlns:a16="http://schemas.microsoft.com/office/drawing/2014/main" id="{5C17D1F0-B585-FB46-9C70-FC0F11EC9422}"/>
+                </a:ext>
+              </a:extLst>
+            </p:cNvPr>
+            <p:cNvSpPr txBox="1"/>
+            <p:nvPr/>
+          </p:nvSpPr>
+          <p:spPr>
+            <a:xfrm>
+              <a:off x="1099228" y="5641374"/>
+              <a:ext cx="2793268" cy="276999"/>
+            </a:xfrm>
+            <a:prstGeom prst="rect">
+              <a:avLst/>
+            </a:prstGeom>
+            <a:noFill/>
+          </p:spPr>
+          <p:txBody>
+            <a:bodyPr wrap="square" rtlCol="0">
+              <a:spAutoFit/>
+            </a:bodyPr>
+            <a:lstStyle/>
+            <a:p>
+              <a:r>
+                <a:rPr lang="en-US" sz="1200" dirty="0">
+                  <a:latin typeface="Arial" panose="020B0604020202020204" pitchFamily="34" charset="0"/>
+                  <a:cs typeface="Arial" panose="020B0604020202020204" pitchFamily="34" charset="0"/>
+                </a:rPr>
+                <a:t>A set should contain unique contacts. </a:t>
+              </a:r>
+            </a:p>
+          </p:txBody>
+        </p:sp>
+      </p:grpSp>
+      <p:sp>
+        <p:nvSpPr>
+          <p:cNvPr id="86" name="TextBox 85">
+            <a:extLst>
+              <a:ext uri="{FF2B5EF4-FFF2-40B4-BE49-F238E27FC236}">
+                <a16:creationId xmlns:a16="http://schemas.microsoft.com/office/drawing/2014/main" id="{C8EE6E1A-464F-C84F-823F-018D466BC27C}"/>
+              </a:ext>
+            </a:extLst>
+          </p:cNvPr>
+          <p:cNvSpPr txBox="1"/>
+          <p:nvPr/>
+        </p:nvSpPr>
+        <p:spPr>
+          <a:xfrm>
+            <a:off x="5750831" y="114169"/>
+            <a:ext cx="933657" cy="369332"/>
+          </a:xfrm>
+          <a:prstGeom prst="rect">
+            <a:avLst/>
+          </a:prstGeom>
+          <a:noFill/>
+        </p:spPr>
+        <p:txBody>
+          <a:bodyPr wrap="square" rtlCol="0">
+            <a:spAutoFit/>
+          </a:bodyPr>
+          <a:lstStyle/>
+          <a:p>
+            <a:r>
+              <a:rPr lang="en-US" b="1" dirty="0">
+                <a:latin typeface="Arial" panose="020B0604020202020204" pitchFamily="34" charset="0"/>
+                <a:cs typeface="Arial" panose="020B0604020202020204" pitchFamily="34" charset="0"/>
+              </a:rPr>
+              <a:t>TASK:</a:t>
+            </a:r>
+          </a:p>
+        </p:txBody>
+      </p:sp>
+    </p:spTree>
+    <p:extLst>
+      <p:ext uri="{BB962C8B-B14F-4D97-AF65-F5344CB8AC3E}">
+        <p14:creationId xmlns:p14="http://schemas.microsoft.com/office/powerpoint/2010/main" val="1575848065"/>
+      </p:ext>
+    </p:extLst>
+  </p:cSld>
+  <p:clrMapOvr>
+    <a:masterClrMapping/>
+  </p:clrMapOvr>
+</p:sld>
+</file>
+
+<file path=ppt/slides/slide2.xml><?xml version="1.0" encoding="utf-8"?>
 <p:sld xmlns:a="http://schemas.openxmlformats.org/drawingml/2006/main" xmlns:r="http://schemas.openxmlformats.org/officeDocument/2006/relationships" xmlns:p="http://schemas.openxmlformats.org/presentationml/2006/main">
   <p:cSld>
     <p:spTree>
@@ -3510,8 +6180,8 @@
           </a:prstGeom>
         </p:spPr>
       </p:pic>
-      <mc:AlternateContent xmlns:mc="http://schemas.openxmlformats.org/markup-compatibility/2006" xmlns:p14="http://schemas.microsoft.com/office/powerpoint/2010/main">
-        <mc:Choice Requires="p14">
+      <mc:AlternateContent xmlns:mc="http://schemas.openxmlformats.org/markup-compatibility/2006">
+        <mc:Choice xmlns:p14="http://schemas.microsoft.com/office/powerpoint/2010/main" Requires="p14">
           <p:contentPart p14:bwMode="auto" r:id="rId4">
             <p14:nvContentPartPr>
               <p14:cNvPr id="30" name="Ink 29">
@@ -3530,7 +6200,7 @@
             </p14:xfrm>
           </p:contentPart>
         </mc:Choice>
-        <mc:Fallback xmlns="">
+        <mc:Fallback>
           <p:pic>
             <p:nvPicPr>
               <p:cNvPr id="30" name="Ink 29">
@@ -5548,8 +8218,8 @@
             <a:chExt cx="2832054" cy="1763999"/>
           </a:xfrm>
         </p:grpSpPr>
-        <mc:AlternateContent xmlns:mc="http://schemas.openxmlformats.org/markup-compatibility/2006" xmlns:p14="http://schemas.microsoft.com/office/powerpoint/2010/main">
-          <mc:Choice Requires="p14">
+        <mc:AlternateContent xmlns:mc="http://schemas.openxmlformats.org/markup-compatibility/2006">
+          <mc:Choice xmlns:p14="http://schemas.microsoft.com/office/powerpoint/2010/main" Requires="p14">
             <p:contentPart p14:bwMode="auto" r:id="rId6">
               <p14:nvContentPartPr>
                 <p14:cNvPr id="66" name="Ink 65">
@@ -5568,7 +8238,7 @@
               </p14:xfrm>
             </p:contentPart>
           </mc:Choice>
-          <mc:Fallback xmlns="">
+          <mc:Fallback>
             <p:pic>
               <p:nvPicPr>
                 <p:cNvPr id="66" name="Ink 65">

</xml_diff>